<commit_message>
Updated role on slide + added extension file type to database schema
</commit_message>
<xml_diff>
--- a/docs/Deliverables/Orderly_Slides.pptx
+++ b/docs/Deliverables/Orderly_Slides.pptx
@@ -28090,8 +28090,8 @@
         </p:nvSpPr>
         <p:spPr>
           <a:xfrm>
-            <a:off x="7132320" y="658368"/>
-            <a:ext cx="1554480" cy="146304"/>
+            <a:off x="6959150" y="658368"/>
+            <a:ext cx="1727650" cy="128016"/>
           </a:xfrm>
           <a:prstGeom prst="rect">
             <a:avLst/>
@@ -28112,7 +28112,7 @@
                   <a:srgbClr val="1D9E75"/>
                 </a:solidFill>
               </a:rPr>
-              <a:t>Product Owner</a:t>
+              <a:t>Product Owner | Full Stack Developer</a:t>
             </a:r>
             <a:endParaRPr lang="en-US" sz="700" dirty="0"/>
           </a:p>
@@ -28508,7 +28508,7 @@
         </p:nvSpPr>
         <p:spPr>
           <a:xfrm>
-            <a:off x="4462272" y="1097280"/>
+            <a:off x="4800600" y="1097280"/>
             <a:ext cx="3886200" cy="347472"/>
           </a:xfrm>
           <a:prstGeom prst="rect">
@@ -28546,7 +28546,7 @@
         </p:nvSpPr>
         <p:spPr>
           <a:xfrm>
-            <a:off x="4572000" y="1097280"/>
+            <a:off x="4910328" y="1097280"/>
             <a:ext cx="3657600" cy="347472"/>
           </a:xfrm>
           <a:prstGeom prst="rect">
@@ -29256,7 +29256,7 @@
         </p:nvSpPr>
         <p:spPr>
           <a:xfrm>
-            <a:off x="4462272" y="1536192"/>
+            <a:off x="4800600" y="1536192"/>
             <a:ext cx="3886200" cy="731520"/>
           </a:xfrm>
           <a:prstGeom prst="rect">
@@ -29301,7 +29301,7 @@
         </p:nvSpPr>
         <p:spPr>
           <a:xfrm>
-            <a:off x="4462272" y="1536192"/>
+            <a:off x="4800600" y="1536192"/>
             <a:ext cx="45720" cy="731520"/>
           </a:xfrm>
           <a:prstGeom prst="rect">
@@ -29339,7 +29339,7 @@
         </p:nvSpPr>
         <p:spPr>
           <a:xfrm>
-            <a:off x="4599432" y="1618488"/>
+            <a:off x="4937760" y="1618488"/>
             <a:ext cx="3611880" cy="182880"/>
           </a:xfrm>
           <a:prstGeom prst="rect">
@@ -29381,7 +29381,7 @@
         </p:nvSpPr>
         <p:spPr>
           <a:xfrm>
-            <a:off x="4599432" y="1819656"/>
+            <a:off x="4937760" y="1819656"/>
             <a:ext cx="3611880" cy="365760"/>
           </a:xfrm>
           <a:prstGeom prst="rect">
@@ -29423,7 +29423,7 @@
         </p:nvSpPr>
         <p:spPr>
           <a:xfrm>
-            <a:off x="4462272" y="2331720"/>
+            <a:off x="4800600" y="2331720"/>
             <a:ext cx="3886200" cy="731520"/>
           </a:xfrm>
           <a:prstGeom prst="rect">
@@ -29468,7 +29468,7 @@
         </p:nvSpPr>
         <p:spPr>
           <a:xfrm>
-            <a:off x="4462272" y="2331720"/>
+            <a:off x="4800600" y="2331720"/>
             <a:ext cx="45720" cy="731520"/>
           </a:xfrm>
           <a:prstGeom prst="rect">
@@ -29506,7 +29506,7 @@
         </p:nvSpPr>
         <p:spPr>
           <a:xfrm>
-            <a:off x="4599432" y="2414016"/>
+            <a:off x="4937760" y="2414016"/>
             <a:ext cx="3611880" cy="182880"/>
           </a:xfrm>
           <a:prstGeom prst="rect">
@@ -29548,7 +29548,7 @@
         </p:nvSpPr>
         <p:spPr>
           <a:xfrm>
-            <a:off x="4599432" y="2615184"/>
+            <a:off x="4937760" y="2615184"/>
             <a:ext cx="3611880" cy="365760"/>
           </a:xfrm>
           <a:prstGeom prst="rect">
@@ -29590,7 +29590,7 @@
         </p:nvSpPr>
         <p:spPr>
           <a:xfrm>
-            <a:off x="4462272" y="3127248"/>
+            <a:off x="4800600" y="3127248"/>
             <a:ext cx="3886200" cy="731520"/>
           </a:xfrm>
           <a:prstGeom prst="rect">
@@ -29635,7 +29635,7 @@
         </p:nvSpPr>
         <p:spPr>
           <a:xfrm>
-            <a:off x="4462272" y="3127248"/>
+            <a:off x="4800600" y="3127248"/>
             <a:ext cx="45720" cy="731520"/>
           </a:xfrm>
           <a:prstGeom prst="rect">
@@ -29673,7 +29673,7 @@
         </p:nvSpPr>
         <p:spPr>
           <a:xfrm>
-            <a:off x="4599432" y="3209544"/>
+            <a:off x="4937760" y="3209544"/>
             <a:ext cx="3611880" cy="182880"/>
           </a:xfrm>
           <a:prstGeom prst="rect">
@@ -29715,7 +29715,7 @@
         </p:nvSpPr>
         <p:spPr>
           <a:xfrm>
-            <a:off x="4599432" y="3410712"/>
+            <a:off x="4937760" y="3410712"/>
             <a:ext cx="3611880" cy="365760"/>
           </a:xfrm>
           <a:prstGeom prst="rect">
@@ -29757,7 +29757,7 @@
         </p:nvSpPr>
         <p:spPr>
           <a:xfrm>
-            <a:off x="4462272" y="3922776"/>
+            <a:off x="4800600" y="3922776"/>
             <a:ext cx="3886200" cy="731520"/>
           </a:xfrm>
           <a:prstGeom prst="rect">
@@ -29802,7 +29802,7 @@
         </p:nvSpPr>
         <p:spPr>
           <a:xfrm>
-            <a:off x="4462272" y="3922776"/>
+            <a:off x="4800600" y="3922776"/>
             <a:ext cx="45720" cy="731520"/>
           </a:xfrm>
           <a:prstGeom prst="rect">
@@ -29840,7 +29840,7 @@
         </p:nvSpPr>
         <p:spPr>
           <a:xfrm>
-            <a:off x="4599432" y="4005072"/>
+            <a:off x="4937760" y="4005072"/>
             <a:ext cx="3611880" cy="182880"/>
           </a:xfrm>
           <a:prstGeom prst="rect">
@@ -29882,7 +29882,7 @@
         </p:nvSpPr>
         <p:spPr>
           <a:xfrm>
-            <a:off x="4599432" y="4206240"/>
+            <a:off x="4937760" y="4206240"/>
             <a:ext cx="3611880" cy="365760"/>
           </a:xfrm>
           <a:prstGeom prst="rect">

</xml_diff>

<commit_message>
Include my personal script for PM slides within our Presentation slide deck
See notes sections:
Feel free to add your own scripts or guides to this section!
</commit_message>
<xml_diff>
--- a/docs/Deliverables/Orderly_Slides.pptx
+++ b/docs/Deliverables/Orderly_Slides.pptx
@@ -316,6 +316,79 @@
               <a:rPr lang="en-US" dirty="0"/>
               <a:t>: What is it? (Serina continues..)</a:t>
             </a:r>
+            <a:br>
+              <a:rPr lang="en-US" dirty="0"/>
+            </a:br>
+            <a:br>
+              <a:rPr lang="en-US" dirty="0"/>
+            </a:br>
+            <a:r>
+              <a:rPr lang="en-US" dirty="0"/>
+              <a:t>Hello, and Welcome!</a:t>
+            </a:r>
+            <a:br>
+              <a:rPr lang="en-US" dirty="0"/>
+            </a:br>
+            <a:endParaRPr lang="en-US" dirty="0"/>
+          </a:p>
+          <a:p>
+            <a:r>
+              <a:rPr lang="en-US" dirty="0"/>
+              <a:t>Today marks a huge milestone for our Team and we are excited to both share and showcase our collective efforts brought together by a team dedicated to putting our best efforts forward towards developing our software, Orderly.</a:t>
+            </a:r>
+          </a:p>
+          <a:p>
+            <a:endParaRPr lang="en-US" dirty="0"/>
+          </a:p>
+          <a:p>
+            <a:r>
+              <a:rPr lang="en-US" dirty="0"/>
+              <a:t>My name is Serina, and I am both the Project Manager and SCRUM Master for a team of 6 academic developers. </a:t>
+            </a:r>
+          </a:p>
+          <a:p>
+            <a:endParaRPr lang="en-US" dirty="0"/>
+          </a:p>
+          <a:p>
+            <a:r>
+              <a:rPr lang="en-US" dirty="0"/>
+              <a:t>As the PM, I served as the Main facilitator for our software development process. My role was to keep us aligned, moving, and accountable – from our very first planning meeting to shipping version 1.0.0 this week. </a:t>
+            </a:r>
+            <a:br>
+              <a:rPr lang="en-US" dirty="0"/>
+            </a:br>
+            <a:br>
+              <a:rPr lang="en-US" dirty="0"/>
+            </a:br>
+            <a:r>
+              <a:rPr lang="en-US" dirty="0"/>
+              <a:t>But </a:t>
+            </a:r>
+            <a:r>
+              <a:rPr lang="en-US" b="1" dirty="0"/>
+              <a:t>before</a:t>
+            </a:r>
+            <a:r>
+              <a:rPr lang="en-US" b="0" dirty="0"/>
+              <a:t> I talk about </a:t>
+            </a:r>
+            <a:r>
+              <a:rPr lang="en-US" b="0" i="1" dirty="0"/>
+              <a:t>how</a:t>
+            </a:r>
+            <a:r>
+              <a:rPr lang="en-US" b="0" i="0" dirty="0"/>
+              <a:t> we built it – let me tell you </a:t>
+            </a:r>
+            <a:r>
+              <a:rPr lang="en-US" b="0" i="1" dirty="0"/>
+              <a:t>what </a:t>
+            </a:r>
+            <a:r>
+              <a:rPr lang="en-US" b="0" i="0" dirty="0"/>
+              <a:t>we built…</a:t>
+            </a:r>
+            <a:endParaRPr lang="en-US" dirty="0"/>
           </a:p>
         </p:txBody>
       </p:sp>
@@ -1076,6 +1149,227 @@
               <a:rPr lang="en-US" b="0" dirty="0"/>
               <a:t>(Next Slide, whole team ready on standby)</a:t>
             </a:r>
+          </a:p>
+          <a:p>
+            <a:endParaRPr lang="en-US" b="0" dirty="0"/>
+          </a:p>
+          <a:p>
+            <a:r>
+              <a:rPr lang="en-US" dirty="0"/>
+              <a:t>Before I open the floor for questions, I want to close with what this experience </a:t>
+            </a:r>
+            <a:r>
+              <a:rPr lang="en-US" i="1" dirty="0"/>
+              <a:t>actually</a:t>
+            </a:r>
+            <a:r>
+              <a:rPr lang="en-US" dirty="0"/>
+              <a:t> taught us.</a:t>
+            </a:r>
+          </a:p>
+          <a:p>
+            <a:endParaRPr lang="en-US" dirty="0"/>
+          </a:p>
+          <a:p>
+            <a:r>
+              <a:rPr lang="en-US" b="1" dirty="0"/>
+              <a:t>Dependency-first planning </a:t>
+            </a:r>
+            <a:r>
+              <a:rPr lang="en-US" dirty="0"/>
+              <a:t>changed how we worked. </a:t>
+            </a:r>
+          </a:p>
+          <a:p>
+            <a:r>
+              <a:rPr lang="en-US" dirty="0"/>
+              <a:t>Early in the project, we learned the hard way that when one piece arrives late… everything downstream stalls. </a:t>
+            </a:r>
+          </a:p>
+          <a:p>
+            <a:endParaRPr lang="en-US" b="1" dirty="0"/>
+          </a:p>
+          <a:p>
+            <a:r>
+              <a:rPr lang="en-US" b="1" dirty="0"/>
+              <a:t>.. Wave-based delivery </a:t>
+            </a:r>
+            <a:r>
+              <a:rPr lang="en-US" dirty="0"/>
+              <a:t>fixed that — and it's something I'll carry into every project I manage going forward</a:t>
+            </a:r>
+            <a:r>
+              <a:rPr lang="en-US" b="1" dirty="0"/>
+              <a:t>, </a:t>
+            </a:r>
+          </a:p>
+          <a:p>
+            <a:r>
+              <a:rPr lang="en-US" b="1" dirty="0"/>
+              <a:t>or at the very least…</a:t>
+            </a:r>
+            <a:r>
+              <a:rPr lang="en-US" dirty="0"/>
+              <a:t> having a contingency plan for dependencies.</a:t>
+            </a:r>
+            <a:br>
+              <a:rPr lang="en-US" dirty="0"/>
+            </a:br>
+            <a:endParaRPr lang="en-US" dirty="0"/>
+          </a:p>
+          <a:p>
+            <a:r>
+              <a:rPr lang="en-US" b="1" dirty="0"/>
+              <a:t>Vocabulary matters more than we expected</a:t>
+            </a:r>
+            <a:r>
+              <a:rPr lang="en-US" dirty="0"/>
+              <a:t>. Understanding the language of APIs, endpoints, and contracts earlier would have saved us real time across the team. </a:t>
+            </a:r>
+          </a:p>
+          <a:p>
+            <a:r>
+              <a:rPr lang="en-US" dirty="0"/>
+              <a:t>Communication only works when everyone is speaking the </a:t>
+            </a:r>
+            <a:r>
+              <a:rPr lang="en-US" b="1" dirty="0"/>
+              <a:t>same</a:t>
+            </a:r>
+            <a:r>
+              <a:rPr lang="en-US" dirty="0"/>
+              <a:t> language.</a:t>
+            </a:r>
+          </a:p>
+          <a:p>
+            <a:endParaRPr lang="en-US" dirty="0"/>
+          </a:p>
+          <a:p>
+            <a:r>
+              <a:rPr lang="en-US" dirty="0"/>
+              <a:t>Importantly, </a:t>
+            </a:r>
+            <a:r>
+              <a:rPr lang="en-US" i="1" dirty="0"/>
+              <a:t>Collaborative development is a skill </a:t>
+            </a:r>
+            <a:r>
+              <a:rPr lang="en-US" dirty="0"/>
+              <a:t>— and it's one we built </a:t>
+            </a:r>
+            <a:r>
+              <a:rPr lang="en-US" b="1" dirty="0"/>
+              <a:t>sprint over sprint</a:t>
+            </a:r>
+            <a:r>
+              <a:rPr lang="en-US" dirty="0"/>
+              <a:t>. </a:t>
+            </a:r>
+          </a:p>
+          <a:p>
+            <a:r>
+              <a:rPr lang="en-US" dirty="0"/>
+              <a:t>Better PR habits, better check-ins, better handoffs. It didn't happen overnight, but </a:t>
+            </a:r>
+            <a:r>
+              <a:rPr lang="en-US" b="1" i="1" dirty="0"/>
+              <a:t>it</a:t>
+            </a:r>
+            <a:r>
+              <a:rPr lang="en-US" dirty="0"/>
+              <a:t> </a:t>
+            </a:r>
+            <a:r>
+              <a:rPr lang="en-US" b="1" i="1" dirty="0"/>
+              <a:t>happened</a:t>
+            </a:r>
+            <a:r>
+              <a:rPr lang="en-US" dirty="0"/>
+              <a:t>.</a:t>
+            </a:r>
+          </a:p>
+          <a:p>
+            <a:endParaRPr lang="en-US" dirty="0"/>
+          </a:p>
+          <a:p>
+            <a:r>
+              <a:rPr lang="en-US" dirty="0"/>
+              <a:t>And lastly, Agile works when the team owns it. </a:t>
+            </a:r>
+          </a:p>
+          <a:p>
+            <a:r>
+              <a:rPr lang="en-US" dirty="0"/>
+              <a:t>We didn't just note our retrospective actions. We </a:t>
+            </a:r>
+            <a:r>
+              <a:rPr lang="en-US" b="1" dirty="0"/>
+              <a:t>acted on </a:t>
+            </a:r>
+            <a:r>
+              <a:rPr lang="en-US" dirty="0"/>
+              <a:t>them. Every sprint closed </a:t>
+            </a:r>
+            <a:r>
+              <a:rPr lang="en-US" i="1" dirty="0"/>
+              <a:t>better than</a:t>
+            </a:r>
+            <a:r>
+              <a:rPr lang="en-US" dirty="0"/>
+              <a:t> the one before it.</a:t>
+            </a:r>
+          </a:p>
+          <a:p>
+            <a:endParaRPr lang="en-US" dirty="0"/>
+          </a:p>
+          <a:p>
+            <a:r>
+              <a:rPr lang="en-US" dirty="0"/>
+              <a:t>We built something real. A platform that looks, works, and ships like professional software. </a:t>
+            </a:r>
+          </a:p>
+          <a:p>
+            <a:r>
+              <a:rPr lang="en-US" dirty="0"/>
+              <a:t>And we built it together — as </a:t>
+            </a:r>
+            <a:r>
+              <a:rPr lang="en-US" b="1" dirty="0"/>
+              <a:t>academic</a:t>
+            </a:r>
+            <a:r>
+              <a:rPr lang="en-US" dirty="0"/>
+              <a:t> </a:t>
+            </a:r>
+            <a:r>
+              <a:rPr lang="en-US" i="1" dirty="0"/>
+              <a:t>software developers</a:t>
+            </a:r>
+            <a:r>
+              <a:rPr lang="en-US" dirty="0"/>
+              <a:t>. 👏</a:t>
+            </a:r>
+          </a:p>
+          <a:p>
+            <a:endParaRPr lang="en-US" dirty="0"/>
+          </a:p>
+          <a:p>
+            <a:r>
+              <a:rPr lang="en-US" dirty="0"/>
+              <a:t>Thank you. </a:t>
+            </a:r>
+          </a:p>
+          <a:p>
+            <a:r>
+              <a:rPr lang="en-US" dirty="0"/>
+              <a:t>We'll now open the floor for questions — before we bring everything together with a demo, </a:t>
+            </a:r>
+          </a:p>
+          <a:p>
+            <a:r>
+              <a:rPr lang="en-US" dirty="0"/>
+              <a:t>built and delivered by your team of dedicated Project Capstone students.</a:t>
+            </a:r>
             <a:endParaRPr lang="en-US" b="1" dirty="0"/>
           </a:p>
         </p:txBody>
@@ -1871,6 +2165,73 @@
               <a:rPr lang="en-US" dirty="0"/>
               <a:t>To share what our team development delivered and how we scoped it all out!</a:t>
             </a:r>
+          </a:p>
+          <a:p>
+            <a:endParaRPr lang="en-US" dirty="0"/>
+          </a:p>
+          <a:p>
+            <a:r>
+              <a:rPr lang="en-US" b="1" u="sng" dirty="0"/>
+              <a:t>Script</a:t>
+            </a:r>
+            <a:r>
+              <a:rPr lang="en-US" dirty="0"/>
+              <a:t>:</a:t>
+            </a:r>
+          </a:p>
+          <a:p>
+            <a:r>
+              <a:rPr lang="en-US" dirty="0"/>
+              <a:t>So let me walk you through how we actually built this.</a:t>
+            </a:r>
+          </a:p>
+          <a:p>
+            <a:endParaRPr lang="en-US" dirty="0"/>
+          </a:p>
+          <a:p>
+            <a:r>
+              <a:rPr lang="en-US" dirty="0"/>
+              <a:t>We followed an Agile Scrum methodology across five two-week sprints, running from January through April. Each sprint had a clear focus — we started with Foundation, laying out our architecture, standards, and development environment. From there we built up our data layer, then our engineering backbone, then the full customer experience, and finally the business admin tools.</a:t>
+            </a:r>
+          </a:p>
+          <a:p>
+            <a:endParaRPr lang="en-US" dirty="0"/>
+          </a:p>
+          <a:p>
+            <a:r>
+              <a:rPr lang="en-US" dirty="0"/>
+              <a:t>The timeline on this slide tells that story. </a:t>
+            </a:r>
+          </a:p>
+          <a:p>
+            <a:r>
+              <a:rPr lang="en-US" dirty="0"/>
+              <a:t>You can see the sprint milestones, our spring break, and then the final push — code freeze on April 24th, deployed on the 25th, and here we are today.</a:t>
+            </a:r>
+          </a:p>
+          <a:p>
+            <a:endParaRPr lang="en-US" dirty="0"/>
+          </a:p>
+          <a:p>
+            <a:r>
+              <a:rPr lang="en-US" dirty="0"/>
+              <a:t>Fourteen weeks. Five sprint reviews and retrospectives. Over thirty team meetings. Two Trello boards. One product development plan.</a:t>
+            </a:r>
+          </a:p>
+          <a:p>
+            <a:r>
+              <a:rPr lang="en-US" dirty="0"/>
+              <a:t>…Iteratively built, from the ground up.</a:t>
+            </a:r>
+          </a:p>
+          <a:p>
+            <a:r>
+              <a:rPr lang="en-US" dirty="0"/>
+              <a:t>I'll now hand it over to Kim, our Product Owner, to walk you through what we delivered.</a:t>
+            </a:r>
+          </a:p>
+          <a:p>
+            <a:endParaRPr lang="en-US" dirty="0"/>
           </a:p>
         </p:txBody>
       </p:sp>

</xml_diff>

<commit_message>
Added an additional slide for QA
</commit_message>
<xml_diff>
--- a/docs/Deliverables/Orderly_Slides.pptx
+++ b/docs/Deliverables/Orderly_Slides.pptx
@@ -5,7 +5,7 @@
     <p:sldMasterId id="2147483648" r:id="rId1"/>
   </p:sldMasterIdLst>
   <p:notesMasterIdLst>
-    <p:notesMasterId r:id="rId19"/>
+    <p:notesMasterId r:id="rId20"/>
   </p:notesMasterIdLst>
   <p:sldIdLst>
     <p:sldId id="256" r:id="rId2"/>
@@ -21,10 +21,11 @@
     <p:sldId id="260" r:id="rId12"/>
     <p:sldId id="264" r:id="rId13"/>
     <p:sldId id="263" r:id="rId14"/>
-    <p:sldId id="265" r:id="rId15"/>
-    <p:sldId id="266" r:id="rId16"/>
-    <p:sldId id="267" r:id="rId17"/>
-    <p:sldId id="268" r:id="rId18"/>
+    <p:sldId id="274" r:id="rId15"/>
+    <p:sldId id="265" r:id="rId16"/>
+    <p:sldId id="266" r:id="rId17"/>
+    <p:sldId id="267" r:id="rId18"/>
+    <p:sldId id="268" r:id="rId19"/>
   </p:sldIdLst>
   <p:sldSz cx="9144000" cy="5143500" type="screen16x9"/>
   <p:notesSz cx="5143500" cy="9144000"/>
@@ -905,13 +906,6 @@
           </p:nvPr>
         </p:nvSpPr>
         <p:spPr/>
-        <p:txBody>
-          <a:bodyPr/>
-          <a:lstStyle/>
-          <a:p>
-            <a:endParaRPr lang="en-US"/>
-          </a:p>
-        </p:txBody>
       </p:sp>
       <p:sp>
         <p:nvSpPr>
@@ -928,15 +922,7 @@
           <a:bodyPr/>
           <a:lstStyle/>
           <a:p>
-            <a:r>
-              <a:rPr lang="en-US" b="1" dirty="0"/>
-              <a:t>🟡 Up Next: </a:t>
-            </a:r>
-            <a:r>
-              <a:rPr lang="en-US" b="0" dirty="0"/>
-              <a:t>What does the future hold in upcoming development- (Caleb Continues..)</a:t>
-            </a:r>
-            <a:endParaRPr lang="en-US" b="1" dirty="0"/>
+            <a:endParaRPr lang="en-US" dirty="0"/>
           </a:p>
         </p:txBody>
       </p:sp>
@@ -1029,22 +1015,11 @@
           <a:p>
             <a:r>
               <a:rPr lang="en-US" b="1" dirty="0"/>
-              <a:t>⏭️ Up Next: </a:t>
+              <a:t>🟡 Up Next: </a:t>
             </a:r>
             <a:r>
               <a:rPr lang="en-US" b="0" dirty="0"/>
-              <a:t>Wrap UP (Serina)</a:t>
-            </a:r>
-            <a:br>
-              <a:rPr lang="en-US" b="0" dirty="0"/>
-            </a:br>
-            <a:r>
-              <a:rPr lang="en-US" b="0" dirty="0"/>
-              <a:t>Transition with ”Now back to our PM as she guides us through our final messages ”… </a:t>
-            </a:r>
-            <a:r>
-              <a:rPr lang="en-US" b="0" i="1" dirty="0"/>
-              <a:t>or something similar</a:t>
+              <a:t>What does the future hold in upcoming development- (Caleb Continues..)</a:t>
             </a:r>
             <a:endParaRPr lang="en-US" b="1" dirty="0"/>
           </a:p>
@@ -1139,236 +1114,22 @@
           <a:p>
             <a:r>
               <a:rPr lang="en-US" b="1" dirty="0"/>
-              <a:t>🟡 Up Next: “</a:t>
+              <a:t>⏭️ Up Next: </a:t>
+            </a:r>
+            <a:r>
+              <a:rPr lang="en-US" b="0" dirty="0"/>
+              <a:t>Wrap UP (Serina)</a:t>
+            </a:r>
+            <a:br>
+              <a:rPr lang="en-US" b="0" dirty="0"/>
+            </a:br>
+            <a:r>
+              <a:rPr lang="en-US" b="0" dirty="0"/>
+              <a:t>Transition with ”Now back to our PM as she guides us through our final messages ”… </a:t>
             </a:r>
             <a:r>
               <a:rPr lang="en-US" b="0" i="1" dirty="0"/>
-              <a:t>Before we present our demonstration, we have about ~_____ minutes for questions.” </a:t>
-            </a:r>
-            <a:r>
-              <a:rPr lang="en-US" b="0" dirty="0"/>
-              <a:t>(Next Slide, whole team ready on standby)</a:t>
-            </a:r>
-          </a:p>
-          <a:p>
-            <a:endParaRPr lang="en-US" b="0" dirty="0"/>
-          </a:p>
-          <a:p>
-            <a:r>
-              <a:rPr lang="en-US" dirty="0"/>
-              <a:t>Before I open the floor for questions, I want to close with what this experience </a:t>
-            </a:r>
-            <a:r>
-              <a:rPr lang="en-US" i="1" dirty="0"/>
-              <a:t>actually</a:t>
-            </a:r>
-            <a:r>
-              <a:rPr lang="en-US" dirty="0"/>
-              <a:t> taught us.</a:t>
-            </a:r>
-          </a:p>
-          <a:p>
-            <a:endParaRPr lang="en-US" dirty="0"/>
-          </a:p>
-          <a:p>
-            <a:r>
-              <a:rPr lang="en-US" b="1" dirty="0"/>
-              <a:t>Dependency-first planning </a:t>
-            </a:r>
-            <a:r>
-              <a:rPr lang="en-US" dirty="0"/>
-              <a:t>changed how we worked. </a:t>
-            </a:r>
-          </a:p>
-          <a:p>
-            <a:r>
-              <a:rPr lang="en-US" dirty="0"/>
-              <a:t>Early in the project, we learned the hard way that when one piece arrives late… everything downstream stalls. </a:t>
-            </a:r>
-          </a:p>
-          <a:p>
-            <a:endParaRPr lang="en-US" b="1" dirty="0"/>
-          </a:p>
-          <a:p>
-            <a:r>
-              <a:rPr lang="en-US" b="1" dirty="0"/>
-              <a:t>.. Wave-based delivery </a:t>
-            </a:r>
-            <a:r>
-              <a:rPr lang="en-US" dirty="0"/>
-              <a:t>fixed that — and it's something I'll carry into every project I manage going forward</a:t>
-            </a:r>
-            <a:r>
-              <a:rPr lang="en-US" b="1" dirty="0"/>
-              <a:t>, </a:t>
-            </a:r>
-          </a:p>
-          <a:p>
-            <a:r>
-              <a:rPr lang="en-US" b="1" dirty="0"/>
-              <a:t>or at the very least…</a:t>
-            </a:r>
-            <a:r>
-              <a:rPr lang="en-US" dirty="0"/>
-              <a:t> having a contingency plan for dependencies.</a:t>
-            </a:r>
-            <a:br>
-              <a:rPr lang="en-US" dirty="0"/>
-            </a:br>
-            <a:endParaRPr lang="en-US" dirty="0"/>
-          </a:p>
-          <a:p>
-            <a:r>
-              <a:rPr lang="en-US" b="1" dirty="0"/>
-              <a:t>Vocabulary matters more than we expected</a:t>
-            </a:r>
-            <a:r>
-              <a:rPr lang="en-US" dirty="0"/>
-              <a:t>. Understanding the language of APIs, endpoints, and contracts earlier would have saved us real time across the team. </a:t>
-            </a:r>
-          </a:p>
-          <a:p>
-            <a:r>
-              <a:rPr lang="en-US" dirty="0"/>
-              <a:t>Communication only works when everyone is speaking the </a:t>
-            </a:r>
-            <a:r>
-              <a:rPr lang="en-US" b="1" dirty="0"/>
-              <a:t>same</a:t>
-            </a:r>
-            <a:r>
-              <a:rPr lang="en-US" dirty="0"/>
-              <a:t> language.</a:t>
-            </a:r>
-          </a:p>
-          <a:p>
-            <a:endParaRPr lang="en-US" dirty="0"/>
-          </a:p>
-          <a:p>
-            <a:r>
-              <a:rPr lang="en-US" dirty="0"/>
-              <a:t>Importantly, </a:t>
-            </a:r>
-            <a:r>
-              <a:rPr lang="en-US" i="1" dirty="0"/>
-              <a:t>Collaborative development is a skill </a:t>
-            </a:r>
-            <a:r>
-              <a:rPr lang="en-US" dirty="0"/>
-              <a:t>— and it's one we built </a:t>
-            </a:r>
-            <a:r>
-              <a:rPr lang="en-US" b="1" dirty="0"/>
-              <a:t>sprint over sprint</a:t>
-            </a:r>
-            <a:r>
-              <a:rPr lang="en-US" dirty="0"/>
-              <a:t>. </a:t>
-            </a:r>
-          </a:p>
-          <a:p>
-            <a:r>
-              <a:rPr lang="en-US" dirty="0"/>
-              <a:t>Better PR habits, better check-ins, better handoffs. It didn't happen overnight, but </a:t>
-            </a:r>
-            <a:r>
-              <a:rPr lang="en-US" b="1" i="1" dirty="0"/>
-              <a:t>it</a:t>
-            </a:r>
-            <a:r>
-              <a:rPr lang="en-US" dirty="0"/>
-              <a:t> </a:t>
-            </a:r>
-            <a:r>
-              <a:rPr lang="en-US" b="1" i="1" dirty="0"/>
-              <a:t>happened</a:t>
-            </a:r>
-            <a:r>
-              <a:rPr lang="en-US" dirty="0"/>
-              <a:t>.</a:t>
-            </a:r>
-          </a:p>
-          <a:p>
-            <a:endParaRPr lang="en-US" dirty="0"/>
-          </a:p>
-          <a:p>
-            <a:r>
-              <a:rPr lang="en-US" dirty="0"/>
-              <a:t>And lastly, Agile works when the team owns it. </a:t>
-            </a:r>
-          </a:p>
-          <a:p>
-            <a:r>
-              <a:rPr lang="en-US" dirty="0"/>
-              <a:t>We didn't just note our retrospective actions. We </a:t>
-            </a:r>
-            <a:r>
-              <a:rPr lang="en-US" b="1" dirty="0"/>
-              <a:t>acted on </a:t>
-            </a:r>
-            <a:r>
-              <a:rPr lang="en-US" dirty="0"/>
-              <a:t>them. Every sprint closed </a:t>
-            </a:r>
-            <a:r>
-              <a:rPr lang="en-US" i="1" dirty="0"/>
-              <a:t>better than</a:t>
-            </a:r>
-            <a:r>
-              <a:rPr lang="en-US" dirty="0"/>
-              <a:t> the one before it.</a:t>
-            </a:r>
-          </a:p>
-          <a:p>
-            <a:endParaRPr lang="en-US" dirty="0"/>
-          </a:p>
-          <a:p>
-            <a:r>
-              <a:rPr lang="en-US" dirty="0"/>
-              <a:t>We built something real. A platform that looks, works, and ships like professional software. </a:t>
-            </a:r>
-          </a:p>
-          <a:p>
-            <a:r>
-              <a:rPr lang="en-US" dirty="0"/>
-              <a:t>And we built it together — as </a:t>
-            </a:r>
-            <a:r>
-              <a:rPr lang="en-US" b="1" dirty="0"/>
-              <a:t>academic</a:t>
-            </a:r>
-            <a:r>
-              <a:rPr lang="en-US" dirty="0"/>
-              <a:t> </a:t>
-            </a:r>
-            <a:r>
-              <a:rPr lang="en-US" i="1" dirty="0"/>
-              <a:t>software developers</a:t>
-            </a:r>
-            <a:r>
-              <a:rPr lang="en-US" dirty="0"/>
-              <a:t>. 👏</a:t>
-            </a:r>
-          </a:p>
-          <a:p>
-            <a:endParaRPr lang="en-US" dirty="0"/>
-          </a:p>
-          <a:p>
-            <a:r>
-              <a:rPr lang="en-US" dirty="0"/>
-              <a:t>Thank you. </a:t>
-            </a:r>
-          </a:p>
-          <a:p>
-            <a:r>
-              <a:rPr lang="en-US" dirty="0"/>
-              <a:t>We'll now open the floor for questions — before we bring everything together with a demo, </a:t>
-            </a:r>
-          </a:p>
-          <a:p>
-            <a:r>
-              <a:rPr lang="en-US" dirty="0"/>
-              <a:t>built and delivered by your team of dedicated Project Capstone students.</a:t>
+              <a:t>or something similar</a:t>
             </a:r>
             <a:endParaRPr lang="en-US" b="1" dirty="0"/>
           </a:p>
@@ -1462,9 +1223,239 @@
           <a:lstStyle/>
           <a:p>
             <a:r>
+              <a:rPr lang="en-US" b="1" dirty="0"/>
+              <a:t>🟡 Up Next: “</a:t>
+            </a:r>
+            <a:r>
+              <a:rPr lang="en-US" b="0" i="1" dirty="0"/>
+              <a:t>Before we present our demonstration, we have about ~_____ minutes for questions.” </a:t>
+            </a:r>
+            <a:r>
+              <a:rPr lang="en-US" b="0" dirty="0"/>
+              <a:t>(Next Slide, whole team ready on standby)</a:t>
+            </a:r>
+          </a:p>
+          <a:p>
+            <a:endParaRPr lang="en-US" b="0" dirty="0"/>
+          </a:p>
+          <a:p>
+            <a:r>
               <a:rPr lang="en-US" dirty="0"/>
-              <a:t>All team members should be prepared to step forward to answer any questions respectively</a:t>
-            </a:r>
+              <a:t>Before I open the floor for questions, I want to close with what this experience </a:t>
+            </a:r>
+            <a:r>
+              <a:rPr lang="en-US" i="1" dirty="0"/>
+              <a:t>actually</a:t>
+            </a:r>
+            <a:r>
+              <a:rPr lang="en-US" dirty="0"/>
+              <a:t> taught us.</a:t>
+            </a:r>
+          </a:p>
+          <a:p>
+            <a:endParaRPr lang="en-US" dirty="0"/>
+          </a:p>
+          <a:p>
+            <a:r>
+              <a:rPr lang="en-US" b="1" dirty="0"/>
+              <a:t>Dependency-first planning </a:t>
+            </a:r>
+            <a:r>
+              <a:rPr lang="en-US" dirty="0"/>
+              <a:t>changed how we worked. </a:t>
+            </a:r>
+          </a:p>
+          <a:p>
+            <a:r>
+              <a:rPr lang="en-US" dirty="0"/>
+              <a:t>Early in the project, we learned the hard way that when one piece arrives late… everything downstream stalls. </a:t>
+            </a:r>
+          </a:p>
+          <a:p>
+            <a:endParaRPr lang="en-US" b="1" dirty="0"/>
+          </a:p>
+          <a:p>
+            <a:r>
+              <a:rPr lang="en-US" b="1" dirty="0"/>
+              <a:t>.. Wave-based delivery </a:t>
+            </a:r>
+            <a:r>
+              <a:rPr lang="en-US" dirty="0"/>
+              <a:t>fixed that — and it's something I'll carry into every project I manage going forward</a:t>
+            </a:r>
+            <a:r>
+              <a:rPr lang="en-US" b="1" dirty="0"/>
+              <a:t>, </a:t>
+            </a:r>
+          </a:p>
+          <a:p>
+            <a:r>
+              <a:rPr lang="en-US" b="1" dirty="0"/>
+              <a:t>or at the very least…</a:t>
+            </a:r>
+            <a:r>
+              <a:rPr lang="en-US" dirty="0"/>
+              <a:t> having a contingency plan for dependencies.</a:t>
+            </a:r>
+            <a:br>
+              <a:rPr lang="en-US" dirty="0"/>
+            </a:br>
+            <a:endParaRPr lang="en-US" dirty="0"/>
+          </a:p>
+          <a:p>
+            <a:r>
+              <a:rPr lang="en-US" b="1" dirty="0"/>
+              <a:t>Vocabulary matters more than we expected</a:t>
+            </a:r>
+            <a:r>
+              <a:rPr lang="en-US" dirty="0"/>
+              <a:t>. Understanding the language of APIs, endpoints, and contracts earlier would have saved us real time across the team. </a:t>
+            </a:r>
+          </a:p>
+          <a:p>
+            <a:r>
+              <a:rPr lang="en-US" dirty="0"/>
+              <a:t>Communication only works when everyone is speaking the </a:t>
+            </a:r>
+            <a:r>
+              <a:rPr lang="en-US" b="1" dirty="0"/>
+              <a:t>same</a:t>
+            </a:r>
+            <a:r>
+              <a:rPr lang="en-US" dirty="0"/>
+              <a:t> language.</a:t>
+            </a:r>
+          </a:p>
+          <a:p>
+            <a:endParaRPr lang="en-US" dirty="0"/>
+          </a:p>
+          <a:p>
+            <a:r>
+              <a:rPr lang="en-US" dirty="0"/>
+              <a:t>Importantly, </a:t>
+            </a:r>
+            <a:r>
+              <a:rPr lang="en-US" i="1" dirty="0"/>
+              <a:t>Collaborative development is a skill </a:t>
+            </a:r>
+            <a:r>
+              <a:rPr lang="en-US" dirty="0"/>
+              <a:t>— and it's one we built </a:t>
+            </a:r>
+            <a:r>
+              <a:rPr lang="en-US" b="1" dirty="0"/>
+              <a:t>sprint over sprint</a:t>
+            </a:r>
+            <a:r>
+              <a:rPr lang="en-US" dirty="0"/>
+              <a:t>. </a:t>
+            </a:r>
+          </a:p>
+          <a:p>
+            <a:r>
+              <a:rPr lang="en-US" dirty="0"/>
+              <a:t>Better PR habits, better check-ins, better handoffs. It didn't happen overnight, but </a:t>
+            </a:r>
+            <a:r>
+              <a:rPr lang="en-US" b="1" i="1" dirty="0"/>
+              <a:t>it</a:t>
+            </a:r>
+            <a:r>
+              <a:rPr lang="en-US" dirty="0"/>
+              <a:t> </a:t>
+            </a:r>
+            <a:r>
+              <a:rPr lang="en-US" b="1" i="1" dirty="0"/>
+              <a:t>happened</a:t>
+            </a:r>
+            <a:r>
+              <a:rPr lang="en-US" dirty="0"/>
+              <a:t>.</a:t>
+            </a:r>
+          </a:p>
+          <a:p>
+            <a:endParaRPr lang="en-US" dirty="0"/>
+          </a:p>
+          <a:p>
+            <a:r>
+              <a:rPr lang="en-US" dirty="0"/>
+              <a:t>And lastly, Agile works when the team owns it. </a:t>
+            </a:r>
+          </a:p>
+          <a:p>
+            <a:r>
+              <a:rPr lang="en-US" dirty="0"/>
+              <a:t>We didn't just note our retrospective actions. We </a:t>
+            </a:r>
+            <a:r>
+              <a:rPr lang="en-US" b="1" dirty="0"/>
+              <a:t>acted on </a:t>
+            </a:r>
+            <a:r>
+              <a:rPr lang="en-US" dirty="0"/>
+              <a:t>them. Every sprint closed </a:t>
+            </a:r>
+            <a:r>
+              <a:rPr lang="en-US" i="1" dirty="0"/>
+              <a:t>better than</a:t>
+            </a:r>
+            <a:r>
+              <a:rPr lang="en-US" dirty="0"/>
+              <a:t> the one before it.</a:t>
+            </a:r>
+          </a:p>
+          <a:p>
+            <a:endParaRPr lang="en-US" dirty="0"/>
+          </a:p>
+          <a:p>
+            <a:r>
+              <a:rPr lang="en-US" dirty="0"/>
+              <a:t>We built something real. A platform that looks, works, and ships like professional software. </a:t>
+            </a:r>
+          </a:p>
+          <a:p>
+            <a:r>
+              <a:rPr lang="en-US" dirty="0"/>
+              <a:t>And we built it together — as </a:t>
+            </a:r>
+            <a:r>
+              <a:rPr lang="en-US" b="1" dirty="0"/>
+              <a:t>academic</a:t>
+            </a:r>
+            <a:r>
+              <a:rPr lang="en-US" dirty="0"/>
+              <a:t> </a:t>
+            </a:r>
+            <a:r>
+              <a:rPr lang="en-US" i="1" dirty="0"/>
+              <a:t>software developers</a:t>
+            </a:r>
+            <a:r>
+              <a:rPr lang="en-US" dirty="0"/>
+              <a:t>. 👏</a:t>
+            </a:r>
+          </a:p>
+          <a:p>
+            <a:endParaRPr lang="en-US" dirty="0"/>
+          </a:p>
+          <a:p>
+            <a:r>
+              <a:rPr lang="en-US" dirty="0"/>
+              <a:t>Thank you. </a:t>
+            </a:r>
+          </a:p>
+          <a:p>
+            <a:r>
+              <a:rPr lang="en-US" dirty="0"/>
+              <a:t>We'll now open the floor for questions — before we bring everything together with a demo, </a:t>
+            </a:r>
+          </a:p>
+          <a:p>
+            <a:r>
+              <a:rPr lang="en-US" dirty="0"/>
+              <a:t>built and delivered by your team of dedicated Project Capstone students.</a:t>
+            </a:r>
+            <a:endParaRPr lang="en-US" b="1" dirty="0"/>
           </a:p>
         </p:txBody>
       </p:sp>
@@ -1486,6 +1477,100 @@
             <a:fld id="{F7021451-1387-4CA6-816F-3879F97B5CBC}" type="slidenum">
               <a:rPr lang="en-US"/>
               <a:t>17</a:t>
+            </a:fld>
+            <a:endParaRPr lang="en-US"/>
+          </a:p>
+        </p:txBody>
+      </p:sp>
+    </p:spTree>
+    <p:extLst>
+      <p:ext uri="{BB962C8B-B14F-4D97-AF65-F5344CB8AC3E}">
+        <p14:creationId xmlns:p14="http://schemas.microsoft.com/office/powerpoint/2010/main" val="1024086991"/>
+      </p:ext>
+    </p:extLst>
+  </p:cSld>
+  <p:clrMapOvr>
+    <a:masterClrMapping/>
+  </p:clrMapOvr>
+</p:notes>
+</file>
+
+<file path=ppt/notesSlides/notesSlide18.xml><?xml version="1.0" encoding="utf-8"?>
+<p:notes xmlns:a="http://schemas.openxmlformats.org/drawingml/2006/main" xmlns:r="http://schemas.openxmlformats.org/officeDocument/2006/relationships" xmlns:p="http://schemas.openxmlformats.org/presentationml/2006/main">
+  <p:cSld>
+    <p:spTree>
+      <p:nvGrpSpPr>
+        <p:cNvPr id="1" name=""/>
+        <p:cNvGrpSpPr/>
+        <p:nvPr/>
+      </p:nvGrpSpPr>
+      <p:grpSpPr>
+        <a:xfrm>
+          <a:off x="0" y="0"/>
+          <a:ext cx="0" cy="0"/>
+          <a:chOff x="0" y="0"/>
+          <a:chExt cx="0" cy="0"/>
+        </a:xfrm>
+      </p:grpSpPr>
+      <p:sp>
+        <p:nvSpPr>
+          <p:cNvPr id="2" name="Slide Image Placeholder 1"/>
+          <p:cNvSpPr>
+            <a:spLocks noGrp="1" noRot="1" noChangeAspect="1"/>
+          </p:cNvSpPr>
+          <p:nvPr>
+            <p:ph type="sldImg"/>
+          </p:nvPr>
+        </p:nvSpPr>
+        <p:spPr/>
+        <p:txBody>
+          <a:bodyPr/>
+          <a:lstStyle/>
+          <a:p>
+            <a:endParaRPr lang="en-US"/>
+          </a:p>
+        </p:txBody>
+      </p:sp>
+      <p:sp>
+        <p:nvSpPr>
+          <p:cNvPr id="3" name="Notes Placeholder 2"/>
+          <p:cNvSpPr>
+            <a:spLocks noGrp="1"/>
+          </p:cNvSpPr>
+          <p:nvPr>
+            <p:ph type="body" idx="1"/>
+          </p:nvPr>
+        </p:nvSpPr>
+        <p:spPr/>
+        <p:txBody>
+          <a:bodyPr/>
+          <a:lstStyle/>
+          <a:p>
+            <a:r>
+              <a:rPr lang="en-US" dirty="0"/>
+              <a:t>All team members should be prepared to step forward to answer any questions respectively</a:t>
+            </a:r>
+          </a:p>
+        </p:txBody>
+      </p:sp>
+      <p:sp>
+        <p:nvSpPr>
+          <p:cNvPr id="4" name="Slide Number Placeholder 3"/>
+          <p:cNvSpPr>
+            <a:spLocks noGrp="1"/>
+          </p:cNvSpPr>
+          <p:nvPr>
+            <p:ph type="sldNum" sz="quarter" idx="10"/>
+          </p:nvPr>
+        </p:nvSpPr>
+        <p:spPr/>
+        <p:txBody>
+          <a:bodyPr/>
+          <a:lstStyle/>
+          <a:p>
+            <a:fld id="{F7021451-1387-4CA6-816F-3879F97B5CBC}" type="slidenum">
+              <a:rPr lang="en-US"/>
+              <a:t>18</a:t>
             </a:fld>
             <a:endParaRPr lang="en-US"/>
           </a:p>
@@ -10899,6 +10984,934 @@
 
 <file path=ppt/slides/slide14.xml><?xml version="1.0" encoding="utf-8"?>
 <p:sld xmlns:a="http://schemas.openxmlformats.org/drawingml/2006/main" xmlns:r="http://schemas.openxmlformats.org/officeDocument/2006/relationships" xmlns:p="http://schemas.openxmlformats.org/presentationml/2006/main">
+  <p:cSld>
+    <p:bg>
+      <p:bgPr>
+        <a:solidFill>
+          <a:srgbClr val="1A1A2E"/>
+        </a:solidFill>
+        <a:effectLst/>
+      </p:bgPr>
+    </p:bg>
+    <p:spTree>
+      <p:nvGrpSpPr>
+        <p:cNvPr id="1" name=""/>
+        <p:cNvGrpSpPr/>
+        <p:nvPr/>
+      </p:nvGrpSpPr>
+      <p:grpSpPr>
+        <a:xfrm>
+          <a:off x="0" y="0"/>
+          <a:ext cx="0" cy="0"/>
+          <a:chOff x="0" y="0"/>
+          <a:chExt cx="0" cy="0"/>
+        </a:xfrm>
+      </p:grpSpPr>
+      <p:sp>
+        <p:nvSpPr>
+          <p:cNvPr id="5" name="Shape 3"/>
+          <p:cNvSpPr/>
+          <p:nvPr/>
+        </p:nvSpPr>
+        <p:spPr>
+          <a:xfrm>
+            <a:off x="457200" y="1188720"/>
+            <a:ext cx="2606040" cy="2240280"/>
+          </a:xfrm>
+          <a:prstGeom prst="rect">
+            <a:avLst/>
+          </a:prstGeom>
+          <a:solidFill>
+            <a:srgbClr val="FFFFFF"/>
+          </a:solidFill>
+          <a:ln w="12700">
+            <a:solidFill>
+              <a:srgbClr val="FFFFFF"/>
+            </a:solidFill>
+            <a:prstDash val="solid"/>
+          </a:ln>
+          <a:effectLst>
+            <a:outerShdw blurRad="101600" dist="38100" dir="8100000" algn="bl" rotWithShape="0">
+              <a:srgbClr val="000000">
+                <a:alpha val="18000"/>
+              </a:srgbClr>
+            </a:outerShdw>
+          </a:effectLst>
+        </p:spPr>
+        <p:txBody>
+          <a:bodyPr/>
+          <a:lstStyle/>
+          <a:p>
+            <a:endParaRPr lang="en-US"/>
+          </a:p>
+        </p:txBody>
+      </p:sp>
+      <p:sp>
+        <p:nvSpPr>
+          <p:cNvPr id="6" name="Shape 4"/>
+          <p:cNvSpPr/>
+          <p:nvPr/>
+        </p:nvSpPr>
+        <p:spPr>
+          <a:xfrm>
+            <a:off x="457200" y="1188720"/>
+            <a:ext cx="2606040" cy="347472"/>
+          </a:xfrm>
+          <a:prstGeom prst="rect">
+            <a:avLst/>
+          </a:prstGeom>
+          <a:solidFill>
+            <a:srgbClr val="7C3AED"/>
+          </a:solidFill>
+          <a:ln w="12700">
+            <a:solidFill>
+              <a:srgbClr val="7C3AED"/>
+            </a:solidFill>
+            <a:prstDash val="solid"/>
+          </a:ln>
+        </p:spPr>
+        <p:txBody>
+          <a:bodyPr/>
+          <a:lstStyle/>
+          <a:p>
+            <a:endParaRPr lang="en-US"/>
+          </a:p>
+        </p:txBody>
+      </p:sp>
+      <p:pic>
+        <p:nvPicPr>
+          <p:cNvPr id="7" name="Image 0" descr="preencoded.png"/>
+          <p:cNvPicPr>
+            <a:picLocks noChangeAspect="1"/>
+          </p:cNvPicPr>
+          <p:nvPr/>
+        </p:nvPicPr>
+        <p:blipFill>
+          <a:blip r:embed="rId3"/>
+          <a:stretch>
+            <a:fillRect/>
+          </a:stretch>
+        </p:blipFill>
+        <p:spPr>
+          <a:xfrm>
+            <a:off x="594360" y="1252728"/>
+            <a:ext cx="219456" cy="219456"/>
+          </a:xfrm>
+          <a:prstGeom prst="rect">
+            <a:avLst/>
+          </a:prstGeom>
+        </p:spPr>
+      </p:pic>
+      <p:sp>
+        <p:nvSpPr>
+          <p:cNvPr id="8" name="Text 5"/>
+          <p:cNvSpPr/>
+          <p:nvPr/>
+        </p:nvSpPr>
+        <p:spPr>
+          <a:xfrm>
+            <a:off x="859536" y="1225296"/>
+            <a:ext cx="2148840" cy="292608"/>
+          </a:xfrm>
+          <a:prstGeom prst="rect">
+            <a:avLst/>
+          </a:prstGeom>
+          <a:noFill/>
+          <a:ln/>
+        </p:spPr>
+        <p:txBody>
+          <a:bodyPr wrap="square" lIns="0" tIns="0" rIns="0" bIns="0" rtlCol="0" anchor="ctr"/>
+          <a:lstStyle/>
+          <a:p>
+            <a:pPr marL="0" indent="0">
+              <a:buNone/>
+            </a:pPr>
+            <a:r>
+              <a:rPr lang="en-US" sz="1100" b="1" dirty="0">
+                <a:solidFill>
+                  <a:srgbClr val="FFFFFF"/>
+                </a:solidFill>
+                <a:latin typeface="Calibri" pitchFamily="34" charset="0"/>
+                <a:ea typeface="Calibri" pitchFamily="34" charset="-122"/>
+                <a:cs typeface="Calibri" pitchFamily="34" charset="-120"/>
+              </a:rPr>
+              <a:t>The Challenge</a:t>
+            </a:r>
+            <a:endParaRPr lang="en-US" sz="1100" dirty="0"/>
+          </a:p>
+        </p:txBody>
+      </p:sp>
+      <p:sp>
+        <p:nvSpPr>
+          <p:cNvPr id="9" name="Text 6"/>
+          <p:cNvSpPr/>
+          <p:nvPr/>
+        </p:nvSpPr>
+        <p:spPr>
+          <a:xfrm>
+            <a:off x="594360" y="1627632"/>
+            <a:ext cx="2331720" cy="1737360"/>
+          </a:xfrm>
+          <a:prstGeom prst="rect">
+            <a:avLst/>
+          </a:prstGeom>
+          <a:noFill/>
+          <a:ln/>
+        </p:spPr>
+        <p:txBody>
+          <a:bodyPr wrap="square" rtlCol="0" anchor="t"/>
+          <a:lstStyle/>
+          <a:p>
+            <a:pPr marL="0" indent="0">
+              <a:buNone/>
+            </a:pPr>
+            <a:r>
+              <a:rPr lang="en-US" sz="1000" b="1" dirty="0">
+                <a:solidFill>
+                  <a:srgbClr val="1A1A2E"/>
+                </a:solidFill>
+                <a:latin typeface="Calibri" pitchFamily="34" charset="0"/>
+                <a:ea typeface="Calibri" pitchFamily="34" charset="-122"/>
+                <a:cs typeface="Calibri" pitchFamily="34" charset="-120"/>
+              </a:rPr>
+              <a:t>Feature Area / Test Name
+</a:t>
+            </a:r>
+            <a:endParaRPr lang="en-US" sz="1000" dirty="0"/>
+          </a:p>
+          <a:p>
+            <a:pPr marL="0" indent="0">
+              <a:buNone/>
+            </a:pPr>
+            <a:r>
+              <a:rPr lang="en-US" sz="1000" dirty="0">
+                <a:solidFill>
+                  <a:srgbClr val="64748B"/>
+                </a:solidFill>
+                <a:latin typeface="Calibri" pitchFamily="34" charset="0"/>
+                <a:ea typeface="Calibri" pitchFamily="34" charset="-122"/>
+                <a:cs typeface="Calibri" pitchFamily="34" charset="-120"/>
+              </a:rPr>
+              <a:t>[Placeholder: Describe what this test was validating — e.g., role-based access control on admin routes, or end-to-end order submission flow.]</a:t>
+            </a:r>
+            <a:endParaRPr lang="en-US" sz="1000" dirty="0"/>
+          </a:p>
+        </p:txBody>
+      </p:sp>
+      <p:sp>
+        <p:nvSpPr>
+          <p:cNvPr id="10" name="Shape 7"/>
+          <p:cNvSpPr/>
+          <p:nvPr/>
+        </p:nvSpPr>
+        <p:spPr>
+          <a:xfrm>
+            <a:off x="3273552" y="1188720"/>
+            <a:ext cx="2606040" cy="2240280"/>
+          </a:xfrm>
+          <a:prstGeom prst="rect">
+            <a:avLst/>
+          </a:prstGeom>
+          <a:solidFill>
+            <a:srgbClr val="FFFFFF"/>
+          </a:solidFill>
+          <a:ln w="12700">
+            <a:solidFill>
+              <a:srgbClr val="FFFFFF"/>
+            </a:solidFill>
+            <a:prstDash val="solid"/>
+          </a:ln>
+          <a:effectLst>
+            <a:outerShdw blurRad="101600" dist="38100" dir="8100000" algn="bl" rotWithShape="0">
+              <a:srgbClr val="000000">
+                <a:alpha val="18000"/>
+              </a:srgbClr>
+            </a:outerShdw>
+          </a:effectLst>
+        </p:spPr>
+        <p:txBody>
+          <a:bodyPr/>
+          <a:lstStyle/>
+          <a:p>
+            <a:endParaRPr lang="en-US"/>
+          </a:p>
+        </p:txBody>
+      </p:sp>
+      <p:sp>
+        <p:nvSpPr>
+          <p:cNvPr id="11" name="Shape 8"/>
+          <p:cNvSpPr/>
+          <p:nvPr/>
+        </p:nvSpPr>
+        <p:spPr>
+          <a:xfrm>
+            <a:off x="3273552" y="1188720"/>
+            <a:ext cx="2606040" cy="347472"/>
+          </a:xfrm>
+          <a:prstGeom prst="rect">
+            <a:avLst/>
+          </a:prstGeom>
+          <a:solidFill>
+            <a:srgbClr val="1E3A5F"/>
+          </a:solidFill>
+          <a:ln w="12700">
+            <a:solidFill>
+              <a:srgbClr val="1E3A5F"/>
+            </a:solidFill>
+            <a:prstDash val="solid"/>
+          </a:ln>
+        </p:spPr>
+        <p:txBody>
+          <a:bodyPr/>
+          <a:lstStyle/>
+          <a:p>
+            <a:endParaRPr lang="en-US"/>
+          </a:p>
+        </p:txBody>
+      </p:sp>
+      <p:pic>
+        <p:nvPicPr>
+          <p:cNvPr id="12" name="Image 1" descr="preencoded.png"/>
+          <p:cNvPicPr>
+            <a:picLocks noChangeAspect="1"/>
+          </p:cNvPicPr>
+          <p:nvPr/>
+        </p:nvPicPr>
+        <p:blipFill>
+          <a:blip r:embed="rId4"/>
+          <a:stretch>
+            <a:fillRect/>
+          </a:stretch>
+        </p:blipFill>
+        <p:spPr>
+          <a:xfrm>
+            <a:off x="3410712" y="1252728"/>
+            <a:ext cx="219456" cy="219456"/>
+          </a:xfrm>
+          <a:prstGeom prst="rect">
+            <a:avLst/>
+          </a:prstGeom>
+        </p:spPr>
+      </p:pic>
+      <p:sp>
+        <p:nvSpPr>
+          <p:cNvPr id="13" name="Text 9"/>
+          <p:cNvSpPr/>
+          <p:nvPr/>
+        </p:nvSpPr>
+        <p:spPr>
+          <a:xfrm>
+            <a:off x="3675888" y="1225296"/>
+            <a:ext cx="2148840" cy="292608"/>
+          </a:xfrm>
+          <a:prstGeom prst="rect">
+            <a:avLst/>
+          </a:prstGeom>
+          <a:noFill/>
+          <a:ln/>
+        </p:spPr>
+        <p:txBody>
+          <a:bodyPr wrap="square" lIns="0" tIns="0" rIns="0" bIns="0" rtlCol="0" anchor="ctr"/>
+          <a:lstStyle/>
+          <a:p>
+            <a:pPr marL="0" indent="0">
+              <a:buNone/>
+            </a:pPr>
+            <a:r>
+              <a:rPr lang="en-US" sz="1100" b="1" dirty="0">
+                <a:solidFill>
+                  <a:srgbClr val="FFFFFF"/>
+                </a:solidFill>
+                <a:latin typeface="Calibri" pitchFamily="34" charset="0"/>
+                <a:ea typeface="Calibri" pitchFamily="34" charset="-122"/>
+                <a:cs typeface="Calibri" pitchFamily="34" charset="-120"/>
+              </a:rPr>
+              <a:t>How It Was Identified</a:t>
+            </a:r>
+            <a:endParaRPr lang="en-US" sz="1100" dirty="0"/>
+          </a:p>
+        </p:txBody>
+      </p:sp>
+      <p:sp>
+        <p:nvSpPr>
+          <p:cNvPr id="14" name="Text 10"/>
+          <p:cNvSpPr/>
+          <p:nvPr/>
+        </p:nvSpPr>
+        <p:spPr>
+          <a:xfrm>
+            <a:off x="3410712" y="1627632"/>
+            <a:ext cx="2331720" cy="1737360"/>
+          </a:xfrm>
+          <a:prstGeom prst="rect">
+            <a:avLst/>
+          </a:prstGeom>
+          <a:noFill/>
+          <a:ln/>
+        </p:spPr>
+        <p:txBody>
+          <a:bodyPr wrap="square" rtlCol="0" anchor="t"/>
+          <a:lstStyle/>
+          <a:p>
+            <a:pPr marL="0" indent="0">
+              <a:buNone/>
+            </a:pPr>
+            <a:r>
+              <a:rPr lang="en-US" sz="1000" b="1" dirty="0">
+                <a:solidFill>
+                  <a:srgbClr val="1A1A2E"/>
+                </a:solidFill>
+                <a:latin typeface="Calibri" pitchFamily="34" charset="0"/>
+                <a:ea typeface="Calibri" pitchFamily="34" charset="-122"/>
+                <a:cs typeface="Calibri" pitchFamily="34" charset="-120"/>
+              </a:rPr>
+              <a:t>Detection Method
+</a:t>
+            </a:r>
+            <a:endParaRPr lang="en-US" sz="1000" dirty="0"/>
+          </a:p>
+          <a:p>
+            <a:pPr marL="0" indent="0">
+              <a:buNone/>
+            </a:pPr>
+            <a:r>
+              <a:rPr lang="en-US" sz="1000" dirty="0">
+                <a:solidFill>
+                  <a:srgbClr val="64748B"/>
+                </a:solidFill>
+                <a:latin typeface="Calibri" pitchFamily="34" charset="0"/>
+                <a:ea typeface="Calibri" pitchFamily="34" charset="-122"/>
+                <a:cs typeface="Calibri" pitchFamily="34" charset="-120"/>
+              </a:rPr>
+              <a:t>[Placeholder: How was this caught? Automated test failure, manual QA pass, CI regression run, code review flag? 1–2 sentences on the moment of discovery.]</a:t>
+            </a:r>
+            <a:endParaRPr lang="en-US" sz="1000" dirty="0"/>
+          </a:p>
+        </p:txBody>
+      </p:sp>
+      <p:sp>
+        <p:nvSpPr>
+          <p:cNvPr id="15" name="Shape 11"/>
+          <p:cNvSpPr/>
+          <p:nvPr/>
+        </p:nvSpPr>
+        <p:spPr>
+          <a:xfrm>
+            <a:off x="6089904" y="1188720"/>
+            <a:ext cx="2606040" cy="2240280"/>
+          </a:xfrm>
+          <a:prstGeom prst="rect">
+            <a:avLst/>
+          </a:prstGeom>
+          <a:solidFill>
+            <a:srgbClr val="FFFFFF"/>
+          </a:solidFill>
+          <a:ln w="12700">
+            <a:solidFill>
+              <a:srgbClr val="FFFFFF"/>
+            </a:solidFill>
+            <a:prstDash val="solid"/>
+          </a:ln>
+          <a:effectLst>
+            <a:outerShdw blurRad="101600" dist="38100" dir="8100000" algn="bl" rotWithShape="0">
+              <a:srgbClr val="000000">
+                <a:alpha val="18000"/>
+              </a:srgbClr>
+            </a:outerShdw>
+          </a:effectLst>
+        </p:spPr>
+        <p:txBody>
+          <a:bodyPr/>
+          <a:lstStyle/>
+          <a:p>
+            <a:endParaRPr lang="en-US"/>
+          </a:p>
+        </p:txBody>
+      </p:sp>
+      <p:sp>
+        <p:nvSpPr>
+          <p:cNvPr id="16" name="Shape 12"/>
+          <p:cNvSpPr/>
+          <p:nvPr/>
+        </p:nvSpPr>
+        <p:spPr>
+          <a:xfrm>
+            <a:off x="6089904" y="1188720"/>
+            <a:ext cx="2606040" cy="347472"/>
+          </a:xfrm>
+          <a:prstGeom prst="rect">
+            <a:avLst/>
+          </a:prstGeom>
+          <a:solidFill>
+            <a:srgbClr val="009F6B"/>
+          </a:solidFill>
+          <a:ln w="12700">
+            <a:solidFill>
+              <a:srgbClr val="009F6B"/>
+            </a:solidFill>
+            <a:prstDash val="solid"/>
+          </a:ln>
+        </p:spPr>
+        <p:txBody>
+          <a:bodyPr/>
+          <a:lstStyle/>
+          <a:p>
+            <a:endParaRPr lang="en-US"/>
+          </a:p>
+        </p:txBody>
+      </p:sp>
+      <p:pic>
+        <p:nvPicPr>
+          <p:cNvPr id="17" name="Image 2" descr="preencoded.png"/>
+          <p:cNvPicPr>
+            <a:picLocks noChangeAspect="1"/>
+          </p:cNvPicPr>
+          <p:nvPr/>
+        </p:nvPicPr>
+        <p:blipFill>
+          <a:blip r:embed="rId5"/>
+          <a:stretch>
+            <a:fillRect/>
+          </a:stretch>
+        </p:blipFill>
+        <p:spPr>
+          <a:xfrm>
+            <a:off x="6227064" y="1252728"/>
+            <a:ext cx="219456" cy="219456"/>
+          </a:xfrm>
+          <a:prstGeom prst="rect">
+            <a:avLst/>
+          </a:prstGeom>
+        </p:spPr>
+      </p:pic>
+      <p:sp>
+        <p:nvSpPr>
+          <p:cNvPr id="18" name="Text 13"/>
+          <p:cNvSpPr/>
+          <p:nvPr/>
+        </p:nvSpPr>
+        <p:spPr>
+          <a:xfrm>
+            <a:off x="6492240" y="1225296"/>
+            <a:ext cx="2148840" cy="292608"/>
+          </a:xfrm>
+          <a:prstGeom prst="rect">
+            <a:avLst/>
+          </a:prstGeom>
+          <a:noFill/>
+          <a:ln/>
+        </p:spPr>
+        <p:txBody>
+          <a:bodyPr wrap="square" lIns="0" tIns="0" rIns="0" bIns="0" rtlCol="0" anchor="ctr"/>
+          <a:lstStyle/>
+          <a:p>
+            <a:pPr marL="0" indent="0">
+              <a:buNone/>
+            </a:pPr>
+            <a:r>
+              <a:rPr lang="en-US" sz="1100" b="1" dirty="0">
+                <a:solidFill>
+                  <a:srgbClr val="FFFFFF"/>
+                </a:solidFill>
+                <a:latin typeface="Calibri" pitchFamily="34" charset="0"/>
+                <a:ea typeface="Calibri" pitchFamily="34" charset="-122"/>
+                <a:cs typeface="Calibri" pitchFamily="34" charset="-120"/>
+              </a:rPr>
+              <a:t>Resolution &amp; Outcome</a:t>
+            </a:r>
+            <a:endParaRPr lang="en-US" sz="1100" dirty="0"/>
+          </a:p>
+        </p:txBody>
+      </p:sp>
+      <p:sp>
+        <p:nvSpPr>
+          <p:cNvPr id="19" name="Text 14"/>
+          <p:cNvSpPr/>
+          <p:nvPr/>
+        </p:nvSpPr>
+        <p:spPr>
+          <a:xfrm>
+            <a:off x="6227064" y="1627632"/>
+            <a:ext cx="2331720" cy="1737360"/>
+          </a:xfrm>
+          <a:prstGeom prst="rect">
+            <a:avLst/>
+          </a:prstGeom>
+          <a:noFill/>
+          <a:ln/>
+        </p:spPr>
+        <p:txBody>
+          <a:bodyPr wrap="square" rtlCol="0" anchor="t"/>
+          <a:lstStyle/>
+          <a:p>
+            <a:pPr marL="0" indent="0">
+              <a:buNone/>
+            </a:pPr>
+            <a:r>
+              <a:rPr lang="en-US" sz="1000" b="1" dirty="0">
+                <a:solidFill>
+                  <a:srgbClr val="1A1A2E"/>
+                </a:solidFill>
+                <a:latin typeface="Calibri" pitchFamily="34" charset="0"/>
+                <a:ea typeface="Calibri" pitchFamily="34" charset="-122"/>
+                <a:cs typeface="Calibri" pitchFamily="34" charset="-120"/>
+              </a:rPr>
+              <a:t>Team Collaboration
+</a:t>
+            </a:r>
+            <a:endParaRPr lang="en-US" sz="1000" dirty="0"/>
+          </a:p>
+          <a:p>
+            <a:pPr marL="0" indent="0">
+              <a:buNone/>
+            </a:pPr>
+            <a:r>
+              <a:rPr lang="en-US" sz="1000" dirty="0">
+                <a:solidFill>
+                  <a:srgbClr val="64748B"/>
+                </a:solidFill>
+                <a:latin typeface="Calibri" pitchFamily="34" charset="0"/>
+                <a:ea typeface="Calibri" pitchFamily="34" charset="-122"/>
+                <a:cs typeface="Calibri" pitchFamily="34" charset="-120"/>
+              </a:rPr>
+              <a:t>[Placeholder: Who flagged it, who fixed it, how it was verified. E.g., 'Kenny identified the failure, Tristin traced it to the API layer, Kim deployed the fix — retested and confirmed passing.']</a:t>
+            </a:r>
+            <a:endParaRPr lang="en-US" sz="1000" dirty="0"/>
+          </a:p>
+        </p:txBody>
+      </p:sp>
+      <p:sp>
+        <p:nvSpPr>
+          <p:cNvPr id="20" name="Shape 15"/>
+          <p:cNvSpPr/>
+          <p:nvPr/>
+        </p:nvSpPr>
+        <p:spPr>
+          <a:xfrm>
+            <a:off x="457200" y="3602736"/>
+            <a:ext cx="8321040" cy="1325880"/>
+          </a:xfrm>
+          <a:prstGeom prst="rect">
+            <a:avLst/>
+          </a:prstGeom>
+          <a:solidFill>
+            <a:srgbClr val="0D2137"/>
+          </a:solidFill>
+          <a:ln w="12700">
+            <a:solidFill>
+              <a:srgbClr val="0D2137"/>
+            </a:solidFill>
+            <a:prstDash val="solid"/>
+          </a:ln>
+        </p:spPr>
+        <p:txBody>
+          <a:bodyPr/>
+          <a:lstStyle/>
+          <a:p>
+            <a:endParaRPr lang="en-US"/>
+          </a:p>
+        </p:txBody>
+      </p:sp>
+      <p:sp>
+        <p:nvSpPr>
+          <p:cNvPr id="21" name="Shape 16"/>
+          <p:cNvSpPr/>
+          <p:nvPr/>
+        </p:nvSpPr>
+        <p:spPr>
+          <a:xfrm>
+            <a:off x="457200" y="3602736"/>
+            <a:ext cx="64008" cy="1325880"/>
+          </a:xfrm>
+          <a:prstGeom prst="rect">
+            <a:avLst/>
+          </a:prstGeom>
+          <a:solidFill>
+            <a:srgbClr val="00C896"/>
+          </a:solidFill>
+          <a:ln w="12700">
+            <a:solidFill>
+              <a:srgbClr val="00C896"/>
+            </a:solidFill>
+            <a:prstDash val="solid"/>
+          </a:ln>
+        </p:spPr>
+        <p:txBody>
+          <a:bodyPr/>
+          <a:lstStyle/>
+          <a:p>
+            <a:endParaRPr lang="en-US"/>
+          </a:p>
+        </p:txBody>
+      </p:sp>
+      <p:pic>
+        <p:nvPicPr>
+          <p:cNvPr id="22" name="Image 3" descr="preencoded.png"/>
+          <p:cNvPicPr>
+            <a:picLocks noChangeAspect="1"/>
+          </p:cNvPicPr>
+          <p:nvPr/>
+        </p:nvPicPr>
+        <p:blipFill>
+          <a:blip r:embed="rId6"/>
+          <a:stretch>
+            <a:fillRect/>
+          </a:stretch>
+        </p:blipFill>
+        <p:spPr>
+          <a:xfrm>
+            <a:off x="612648" y="4014216"/>
+            <a:ext cx="320040" cy="320040"/>
+          </a:xfrm>
+          <a:prstGeom prst="rect">
+            <a:avLst/>
+          </a:prstGeom>
+        </p:spPr>
+      </p:pic>
+      <p:sp>
+        <p:nvSpPr>
+          <p:cNvPr id="23" name="Text 17"/>
+          <p:cNvSpPr/>
+          <p:nvPr/>
+        </p:nvSpPr>
+        <p:spPr>
+          <a:xfrm>
+            <a:off x="1051560" y="3739896"/>
+            <a:ext cx="7498080" cy="1097280"/>
+          </a:xfrm>
+          <a:prstGeom prst="rect">
+            <a:avLst/>
+          </a:prstGeom>
+          <a:noFill/>
+          <a:ln/>
+        </p:spPr>
+        <p:txBody>
+          <a:bodyPr wrap="square" rtlCol="0" anchor="t"/>
+          <a:lstStyle/>
+          <a:p>
+            <a:pPr marL="0" indent="0">
+              <a:buNone/>
+            </a:pPr>
+            <a:r>
+              <a:rPr lang="en-US" sz="1100" b="1" dirty="0">
+                <a:solidFill>
+                  <a:srgbClr val="FFFFFF"/>
+                </a:solidFill>
+                <a:latin typeface="Calibri" pitchFamily="34" charset="0"/>
+                <a:ea typeface="Calibri" pitchFamily="34" charset="-122"/>
+                <a:cs typeface="Calibri" pitchFamily="34" charset="-120"/>
+              </a:rPr>
+              <a:t>[ Key Highlight Place Holder ]
+</a:t>
+            </a:r>
+            <a:endParaRPr lang="en-US" sz="1100" dirty="0"/>
+          </a:p>
+          <a:p>
+            <a:pPr marL="0" indent="0">
+              <a:buNone/>
+            </a:pPr>
+            <a:r>
+              <a:rPr lang="en-US" sz="950" i="1" dirty="0">
+                <a:solidFill>
+                  <a:srgbClr val="B0C4D8"/>
+                </a:solidFill>
+                <a:latin typeface="Calibri" pitchFamily="34" charset="0"/>
+                <a:ea typeface="Calibri" pitchFamily="34" charset="-122"/>
+                <a:cs typeface="Calibri" pitchFamily="34" charset="-120"/>
+              </a:rPr>
+              <a:t>"Quality assurance isn't just about coverage numbers — it's about catching the right things at the right time. [This sprint/This test] is an example of the team's process working exactly as intended."</a:t>
+            </a:r>
+            <a:endParaRPr lang="en-US" sz="1100" dirty="0"/>
+          </a:p>
+        </p:txBody>
+      </p:sp>
+      <p:sp>
+        <p:nvSpPr>
+          <p:cNvPr id="24" name="Text 0">
+            <a:extLst>
+              <a:ext uri="{FF2B5EF4-FFF2-40B4-BE49-F238E27FC236}">
+                <a16:creationId xmlns:a16="http://schemas.microsoft.com/office/drawing/2014/main" id="{CE4396FD-BDF5-670C-F4B3-30360F218813}"/>
+              </a:ext>
+            </a:extLst>
+          </p:cNvPr>
+          <p:cNvSpPr/>
+          <p:nvPr/>
+        </p:nvSpPr>
+        <p:spPr>
+          <a:xfrm>
+            <a:off x="457200" y="164592"/>
+            <a:ext cx="8229600" cy="256032"/>
+          </a:xfrm>
+          <a:prstGeom prst="rect">
+            <a:avLst/>
+          </a:prstGeom>
+          <a:noFill/>
+          <a:ln/>
+        </p:spPr>
+        <p:txBody>
+          <a:bodyPr wrap="square" lIns="0" tIns="0" rIns="0" bIns="0" rtlCol="0" anchor="ctr"/>
+          <a:lstStyle/>
+          <a:p>
+            <a:pPr marL="0" indent="0" algn="l">
+              <a:buNone/>
+            </a:pPr>
+            <a:r>
+              <a:rPr lang="en-US" sz="900" b="1" kern="0" spc="300" dirty="0">
+                <a:solidFill>
+                  <a:srgbClr val="3BB77E"/>
+                </a:solidFill>
+                <a:latin typeface="Calibri" pitchFamily="34" charset="0"/>
+                <a:ea typeface="Calibri" pitchFamily="34" charset="-122"/>
+                <a:cs typeface="Calibri" pitchFamily="34" charset="-120"/>
+              </a:rPr>
+              <a:t>TESTING &amp; QUALITY ASSURANCE</a:t>
+            </a:r>
+            <a:endParaRPr lang="en-US" sz="900" dirty="0"/>
+          </a:p>
+        </p:txBody>
+      </p:sp>
+      <p:sp>
+        <p:nvSpPr>
+          <p:cNvPr id="25" name="Text 1">
+            <a:extLst>
+              <a:ext uri="{FF2B5EF4-FFF2-40B4-BE49-F238E27FC236}">
+                <a16:creationId xmlns:a16="http://schemas.microsoft.com/office/drawing/2014/main" id="{59ADE286-38D8-DCFF-A976-DED8A4930314}"/>
+              </a:ext>
+            </a:extLst>
+          </p:cNvPr>
+          <p:cNvSpPr/>
+          <p:nvPr/>
+        </p:nvSpPr>
+        <p:spPr>
+          <a:xfrm>
+            <a:off x="457200" y="475488"/>
+            <a:ext cx="8229600" cy="658368"/>
+          </a:xfrm>
+          <a:prstGeom prst="rect">
+            <a:avLst/>
+          </a:prstGeom>
+          <a:noFill/>
+          <a:ln/>
+        </p:spPr>
+        <p:txBody>
+          <a:bodyPr wrap="square" lIns="0" tIns="0" rIns="0" bIns="0" rtlCol="0" anchor="ctr"/>
+          <a:lstStyle/>
+          <a:p>
+            <a:pPr marL="0" indent="0" algn="l">
+              <a:buNone/>
+            </a:pPr>
+            <a:r>
+              <a:rPr lang="en-US" sz="3200" b="1" dirty="0">
+                <a:solidFill>
+                  <a:schemeClr val="bg1"/>
+                </a:solidFill>
+                <a:latin typeface="Calibri" pitchFamily="34" charset="0"/>
+                <a:cs typeface="Calibri" pitchFamily="34" charset="-120"/>
+              </a:rPr>
+              <a:t>QA in Practice</a:t>
+            </a:r>
+            <a:endParaRPr lang="en-US" sz="3200" dirty="0">
+              <a:solidFill>
+                <a:schemeClr val="bg1"/>
+              </a:solidFill>
+            </a:endParaRPr>
+          </a:p>
+        </p:txBody>
+      </p:sp>
+      <p:sp>
+        <p:nvSpPr>
+          <p:cNvPr id="26" name="Text 2">
+            <a:extLst>
+              <a:ext uri="{FF2B5EF4-FFF2-40B4-BE49-F238E27FC236}">
+                <a16:creationId xmlns:a16="http://schemas.microsoft.com/office/drawing/2014/main" id="{B47AD6B9-62CE-F716-2950-4C29024360E0}"/>
+              </a:ext>
+            </a:extLst>
+          </p:cNvPr>
+          <p:cNvSpPr/>
+          <p:nvPr/>
+        </p:nvSpPr>
+        <p:spPr>
+          <a:xfrm>
+            <a:off x="7132320" y="493776"/>
+            <a:ext cx="1554480" cy="182880"/>
+          </a:xfrm>
+          <a:prstGeom prst="rect">
+            <a:avLst/>
+          </a:prstGeom>
+          <a:noFill/>
+          <a:ln/>
+        </p:spPr>
+        <p:txBody>
+          <a:bodyPr wrap="square" lIns="0" tIns="0" rIns="0" bIns="0" rtlCol="0" anchor="ctr"/>
+          <a:lstStyle/>
+          <a:p>
+            <a:pPr marL="0" indent="0" algn="r">
+              <a:buNone/>
+            </a:pPr>
+            <a:r>
+              <a:rPr lang="en-US" sz="800" dirty="0">
+                <a:solidFill>
+                  <a:srgbClr val="94A3B8"/>
+                </a:solidFill>
+              </a:rPr>
+              <a:t>Kenny Bacdayan</a:t>
+            </a:r>
+            <a:endParaRPr lang="en-US" sz="800" dirty="0"/>
+          </a:p>
+        </p:txBody>
+      </p:sp>
+      <p:sp>
+        <p:nvSpPr>
+          <p:cNvPr id="27" name="Text 3">
+            <a:extLst>
+              <a:ext uri="{FF2B5EF4-FFF2-40B4-BE49-F238E27FC236}">
+                <a16:creationId xmlns:a16="http://schemas.microsoft.com/office/drawing/2014/main" id="{E0AF6E58-2AB3-26D3-3F77-3015CBE22786}"/>
+              </a:ext>
+            </a:extLst>
+          </p:cNvPr>
+          <p:cNvSpPr/>
+          <p:nvPr/>
+        </p:nvSpPr>
+        <p:spPr>
+          <a:xfrm>
+            <a:off x="7132320" y="658368"/>
+            <a:ext cx="1554480" cy="146304"/>
+          </a:xfrm>
+          <a:prstGeom prst="rect">
+            <a:avLst/>
+          </a:prstGeom>
+          <a:noFill/>
+          <a:ln/>
+        </p:spPr>
+        <p:txBody>
+          <a:bodyPr wrap="square" lIns="0" tIns="0" rIns="0" bIns="0" rtlCol="0" anchor="ctr"/>
+          <a:lstStyle/>
+          <a:p>
+            <a:pPr marL="0" indent="0" algn="r">
+              <a:buNone/>
+            </a:pPr>
+            <a:r>
+              <a:rPr lang="en-US" sz="700" b="1" dirty="0">
+                <a:solidFill>
+                  <a:srgbClr val="1D9E75"/>
+                </a:solidFill>
+              </a:rPr>
+              <a:t>Quality Assurance &amp; Testing Lead</a:t>
+            </a:r>
+            <a:endParaRPr lang="en-US" sz="700" dirty="0"/>
+          </a:p>
+        </p:txBody>
+      </p:sp>
+    </p:spTree>
+  </p:cSld>
+  <p:clrMapOvr>
+    <a:masterClrMapping/>
+  </p:clrMapOvr>
+</p:sld>
+</file>
+
+<file path=ppt/slides/slide15.xml><?xml version="1.0" encoding="utf-8"?>
+<p:sld xmlns:a="http://schemas.openxmlformats.org/drawingml/2006/main" xmlns:r="http://schemas.openxmlformats.org/officeDocument/2006/relationships" xmlns:p="http://schemas.openxmlformats.org/presentationml/2006/main">
   <p:cSld name="Slide 10">
     <p:bg>
       <p:bgPr>
@@ -12520,7 +13533,7 @@
 </p:sld>
 </file>
 
-<file path=ppt/slides/slide15.xml><?xml version="1.0" encoding="utf-8"?>
+<file path=ppt/slides/slide16.xml><?xml version="1.0" encoding="utf-8"?>
 <p:sld xmlns:a="http://schemas.openxmlformats.org/drawingml/2006/main" xmlns:r="http://schemas.openxmlformats.org/officeDocument/2006/relationships" xmlns:p="http://schemas.openxmlformats.org/presentationml/2006/main">
   <p:cSld name="Slide 11">
     <p:bg>
@@ -14626,7 +15639,7 @@
 </p:sld>
 </file>
 
-<file path=ppt/slides/slide16.xml><?xml version="1.0" encoding="utf-8"?>
+<file path=ppt/slides/slide17.xml><?xml version="1.0" encoding="utf-8"?>
 <p:sld xmlns:a="http://schemas.openxmlformats.org/drawingml/2006/main" xmlns:r="http://schemas.openxmlformats.org/officeDocument/2006/relationships" xmlns:p="http://schemas.openxmlformats.org/presentationml/2006/main">
   <p:cSld name="Slide 12">
     <p:bg>
@@ -15836,7 +16849,7 @@
 </p:sld>
 </file>
 
-<file path=ppt/slides/slide17.xml><?xml version="1.0" encoding="utf-8"?>
+<file path=ppt/slides/slide18.xml><?xml version="1.0" encoding="utf-8"?>
 <p:sld xmlns:a="http://schemas.openxmlformats.org/drawingml/2006/main" xmlns:r="http://schemas.openxmlformats.org/officeDocument/2006/relationships" xmlns:p="http://schemas.openxmlformats.org/presentationml/2006/main">
   <p:cSld name="Slide 13">
     <p:bg>

</xml_diff>

<commit_message>
Update to Slide 16 (What's Next? Orderly's Future) to address Deployment note
</commit_message>
<xml_diff>
--- a/docs/Deliverables/Orderly_Slides.pptx
+++ b/docs/Deliverables/Orderly_Slides.pptx
@@ -14379,7 +14379,7 @@
                   <a:srgbClr val="4A5568"/>
                 </a:solidFill>
               </a:rPr>
-              <a:t>Order confirmation and status emails — backend hooks are in place, delivery layer is next.</a:t>
+              <a:t>Order confirmation and status emails — backend hooks are in place; delivery layer is next.</a:t>
             </a:r>
             <a:endParaRPr lang="en-US" sz="800" dirty="0"/>
           </a:p>
@@ -15628,6 +15628,167 @@
               <a:t>A tenant model would let Orderly serve multiple businesses from a single deployment.</a:t>
             </a:r>
             <a:endParaRPr lang="en-US" sz="800" dirty="0"/>
+          </a:p>
+        </p:txBody>
+      </p:sp>
+      <p:sp>
+        <p:nvSpPr>
+          <p:cNvPr id="4" name="Shape 25">
+            <a:extLst>
+              <a:ext uri="{FF2B5EF4-FFF2-40B4-BE49-F238E27FC236}">
+                <a16:creationId xmlns:a16="http://schemas.microsoft.com/office/drawing/2014/main" id="{E07E6156-A9E1-AE60-C24F-52C501F161F8}"/>
+              </a:ext>
+            </a:extLst>
+          </p:cNvPr>
+          <p:cNvSpPr/>
+          <p:nvPr/>
+        </p:nvSpPr>
+        <p:spPr>
+          <a:xfrm>
+            <a:off x="6062472" y="2437811"/>
+            <a:ext cx="2377440" cy="6401"/>
+          </a:xfrm>
+          <a:prstGeom prst="rect">
+            <a:avLst/>
+          </a:prstGeom>
+          <a:solidFill>
+            <a:srgbClr val="E2E8F0"/>
+          </a:solidFill>
+          <a:ln w="12700">
+            <a:solidFill>
+              <a:srgbClr val="E2E8F0"/>
+            </a:solidFill>
+            <a:prstDash val="solid"/>
+          </a:ln>
+        </p:spPr>
+        <p:txBody>
+          <a:bodyPr/>
+          <a:lstStyle/>
+          <a:p>
+            <a:endParaRPr lang="en-US"/>
+          </a:p>
+        </p:txBody>
+      </p:sp>
+      <p:sp>
+        <p:nvSpPr>
+          <p:cNvPr id="5" name="Shape 26">
+            <a:extLst>
+              <a:ext uri="{FF2B5EF4-FFF2-40B4-BE49-F238E27FC236}">
+                <a16:creationId xmlns:a16="http://schemas.microsoft.com/office/drawing/2014/main" id="{D676D69A-290F-90AD-5C15-D40AC5CB6639}"/>
+              </a:ext>
+            </a:extLst>
+          </p:cNvPr>
+          <p:cNvSpPr/>
+          <p:nvPr/>
+        </p:nvSpPr>
+        <p:spPr>
+          <a:xfrm>
+            <a:off x="6062472" y="2495154"/>
+            <a:ext cx="444470" cy="111226"/>
+          </a:xfrm>
+          <a:prstGeom prst="rect">
+            <a:avLst/>
+          </a:prstGeom>
+          <a:solidFill>
+            <a:schemeClr val="accent6"/>
+          </a:solidFill>
+          <a:ln w="12700">
+            <a:solidFill>
+              <a:srgbClr val="1D9E75"/>
+            </a:solidFill>
+            <a:prstDash val="solid"/>
+          </a:ln>
+        </p:spPr>
+        <p:txBody>
+          <a:bodyPr/>
+          <a:lstStyle/>
+          <a:p>
+            <a:endParaRPr lang="en-US"/>
+          </a:p>
+        </p:txBody>
+      </p:sp>
+      <p:sp>
+        <p:nvSpPr>
+          <p:cNvPr id="6" name="Text 27">
+            <a:extLst>
+              <a:ext uri="{FF2B5EF4-FFF2-40B4-BE49-F238E27FC236}">
+                <a16:creationId xmlns:a16="http://schemas.microsoft.com/office/drawing/2014/main" id="{72175B81-B914-00A4-4E4E-38C1B6673292}"/>
+              </a:ext>
+            </a:extLst>
+          </p:cNvPr>
+          <p:cNvSpPr/>
+          <p:nvPr/>
+        </p:nvSpPr>
+        <p:spPr>
+          <a:xfrm>
+            <a:off x="6062472" y="2495154"/>
+            <a:ext cx="444470" cy="102461"/>
+          </a:xfrm>
+          <a:prstGeom prst="rect">
+            <a:avLst/>
+          </a:prstGeom>
+          <a:noFill/>
+          <a:ln/>
+        </p:spPr>
+        <p:txBody>
+          <a:bodyPr wrap="square" lIns="0" tIns="0" rIns="0" bIns="0" rtlCol="0" anchor="ctr"/>
+          <a:lstStyle/>
+          <a:p>
+            <a:pPr marL="0" indent="0" algn="ctr">
+              <a:buNone/>
+            </a:pPr>
+            <a:r>
+              <a:rPr lang="en-US" sz="650" b="1" dirty="0">
+                <a:solidFill>
+                  <a:srgbClr val="FFFFFF"/>
+                </a:solidFill>
+              </a:rPr>
+              <a:t>Update!</a:t>
+            </a:r>
+            <a:endParaRPr lang="en-US" sz="650" dirty="0"/>
+          </a:p>
+        </p:txBody>
+      </p:sp>
+      <p:sp>
+        <p:nvSpPr>
+          <p:cNvPr id="7" name="Text 28">
+            <a:extLst>
+              <a:ext uri="{FF2B5EF4-FFF2-40B4-BE49-F238E27FC236}">
+                <a16:creationId xmlns:a16="http://schemas.microsoft.com/office/drawing/2014/main" id="{9B17FE1C-0A8E-03DC-039C-525D7FAF4B75}"/>
+              </a:ext>
+            </a:extLst>
+          </p:cNvPr>
+          <p:cNvSpPr/>
+          <p:nvPr/>
+        </p:nvSpPr>
+        <p:spPr>
+          <a:xfrm>
+            <a:off x="6580094" y="2497847"/>
+            <a:ext cx="1859818" cy="135789"/>
+          </a:xfrm>
+          <a:prstGeom prst="rect">
+            <a:avLst/>
+          </a:prstGeom>
+          <a:noFill/>
+          <a:ln/>
+        </p:spPr>
+        <p:txBody>
+          <a:bodyPr wrap="square" lIns="0" tIns="0" rIns="0" bIns="0" rtlCol="0" anchor="t"/>
+          <a:lstStyle/>
+          <a:p>
+            <a:pPr marL="0" indent="0">
+              <a:buNone/>
+            </a:pPr>
+            <a:r>
+              <a:rPr lang="en-US" sz="700" dirty="0">
+                <a:solidFill>
+                  <a:schemeClr val="accent3">
+                    <a:lumMod val="50000"/>
+                  </a:schemeClr>
+                </a:solidFill>
+              </a:rPr>
+              <a:t>Deployment is LIVE. Requires minor image support</a:t>
+            </a:r>
           </a:p>
         </p:txBody>
       </p:sp>

</xml_diff>

<commit_message>
Updating the slides with scripts
</commit_message>
<xml_diff>
--- a/docs/Deliverables/Orderly_Slides.pptx
+++ b/docs/Deliverables/Orderly_Slides.pptx
@@ -389,6 +389,69 @@
               <a:rPr lang="en-US" b="0" i="0" dirty="0"/>
               <a:t>we built…</a:t>
             </a:r>
+          </a:p>
+          <a:p>
+            <a:endParaRPr lang="en-US" b="0" i="0" dirty="0"/>
+          </a:p>
+          <a:p>
+            <a:endParaRPr lang="en-US" b="0" i="0" dirty="0"/>
+          </a:p>
+          <a:p>
+            <a:r>
+              <a:rPr lang="en-US" b="0" i="0" dirty="0"/>
+              <a:t>OR Tighten it up:</a:t>
+            </a:r>
+          </a:p>
+          <a:p>
+            <a:endParaRPr lang="en-US" b="0" i="0" dirty="0"/>
+          </a:p>
+          <a:p>
+            <a:r>
+              <a:rPr lang="en-US" dirty="0"/>
+              <a:t>Hello, and welcome!</a:t>
+            </a:r>
+          </a:p>
+          <a:p>
+            <a:r>
+              <a:rPr lang="en-US" dirty="0"/>
+              <a:t>Today is a big milestone for our team — and we're excited to share what we've built.</a:t>
+            </a:r>
+          </a:p>
+          <a:p>
+            <a:r>
+              <a:rPr lang="en-US" dirty="0"/>
+              <a:t>My name is Serina. I'm the Project Manager and Scrum Master for Team 7, a group of six student developers here at Wake Tech.</a:t>
+            </a:r>
+          </a:p>
+          <a:p>
+            <a:r>
+              <a:rPr lang="en-US" dirty="0"/>
+              <a:t>As PM, I was the main facilitator for our entire development process — keeping us aligned, moving, and accountable from our very first planning meeting all the way to shipping version 1.0.0 this week.</a:t>
+            </a:r>
+          </a:p>
+          <a:p>
+            <a:r>
+              <a:rPr lang="en-US" dirty="0"/>
+              <a:t>But before I talk about </a:t>
+            </a:r>
+            <a:r>
+              <a:rPr lang="en-US" i="1" dirty="0"/>
+              <a:t>how</a:t>
+            </a:r>
+            <a:r>
+              <a:rPr lang="en-US" dirty="0"/>
+              <a:t> we built it — let me tell you </a:t>
+            </a:r>
+            <a:r>
+              <a:rPr lang="en-US" i="1" dirty="0"/>
+              <a:t>what</a:t>
+            </a:r>
+            <a:r>
+              <a:rPr lang="en-US" dirty="0"/>
+              <a:t> we built.</a:t>
+            </a:r>
+          </a:p>
+          <a:p>
             <a:endParaRPr lang="en-US" dirty="0"/>
           </a:p>
         </p:txBody>
@@ -824,21 +887,64 @@
           <a:lstStyle/>
           <a:p>
             <a:r>
+              <a:rPr lang="en-US" dirty="0"/>
+              <a:t>To show how that worked in practice, here’s one example from our Role Based Access Control testing.</a:t>
+            </a:r>
+          </a:p>
+          <a:p>
+            <a:endParaRPr lang="en-US" dirty="0"/>
+          </a:p>
+          <a:p>
+            <a:r>
+              <a:rPr lang="en-US" dirty="0"/>
+              <a:t>During admin access validation, I identified a defect where logged-out users could directly access an admin route instead of being redirected to login, which introduced a security risk.</a:t>
+            </a:r>
+          </a:p>
+          <a:p>
+            <a:endParaRPr lang="en-US" dirty="0"/>
+          </a:p>
+          <a:p>
+            <a:r>
+              <a:rPr lang="en-US" dirty="0"/>
+              <a:t>I documented the issue through a bug report with reproduction steps and impact. The issue was traced to route protection logic and a fix was implemented. Afterward, I validated the solution through manual retesting and automated regression testing. Then, just as importantly, we added test cases and expanded coverage so the issue wouldn’t reappear.</a:t>
+            </a:r>
+          </a:p>
+          <a:p>
+            <a:endParaRPr lang="en-US" dirty="0"/>
+          </a:p>
+          <a:p>
+            <a:r>
+              <a:rPr lang="en-US" dirty="0"/>
+              <a:t>That reflects our QA workflow:</a:t>
+            </a:r>
+            <a:br>
+              <a:rPr lang="en-US" dirty="0"/>
+            </a:br>
+            <a:r>
               <a:rPr lang="en-US" b="1" dirty="0"/>
-              <a:t>⏭️ Up Next: </a:t>
-            </a:r>
-            <a:r>
-              <a:rPr lang="en-US" b="0" dirty="0"/>
-              <a:t>The Value of Feedback (Caleb)</a:t>
-            </a:r>
-            <a:br>
-              <a:rPr lang="en-US" b="0" dirty="0"/>
-            </a:br>
-            <a:r>
-              <a:rPr lang="en-US" b="0" dirty="0"/>
-              <a:t>Transition with ”Test Results served as valuable feedback amongst other sources within our development, let’s hear more about how”… </a:t>
-            </a:r>
-            <a:endParaRPr lang="en-US" b="1" dirty="0"/>
+              <a:t>Discover, Report, Fix, Retest, and Expand Test Coverage.</a:t>
+            </a:r>
+            <a:endParaRPr lang="en-US" dirty="0"/>
+          </a:p>
+          <a:p>
+            <a:r>
+              <a:rPr lang="en-US" dirty="0"/>
+              <a:t>For me, that captures how QA supported the project — not just identifying issues, but improving long-term reliability throughout development.</a:t>
+            </a:r>
+          </a:p>
+          <a:p>
+            <a:r>
+              <a:rPr lang="en-US" dirty="0"/>
+              <a:t>And with that, I’ll hand it over to Caleb, who will walk through </a:t>
+            </a:r>
+            <a:r>
+              <a:rPr lang="en-US" b="1" dirty="0"/>
+              <a:t>User Feedback</a:t>
+            </a:r>
+            <a:r>
+              <a:rPr lang="en-US" dirty="0"/>
+              <a:t>. Thank you.”</a:t>
+            </a:r>
           </a:p>
         </p:txBody>
       </p:sp>
@@ -922,7 +1028,103 @@
           <a:bodyPr/>
           <a:lstStyle/>
           <a:p>
+            <a:r>
+              <a:rPr lang="en-US" dirty="0"/>
+              <a:t>“Thanks, Tristan — and thanks everyone.</a:t>
+            </a:r>
+          </a:p>
+          <a:p>
+            <a:r>
+              <a:rPr lang="en-US" dirty="0"/>
+              <a:t>Hi, I’m Kenny, and I served as the QA Lead for our project.</a:t>
+            </a:r>
+          </a:p>
+          <a:p>
+            <a:r>
+              <a:rPr lang="en-US" dirty="0"/>
+              <a:t>My role focused on developing and executing our testing and quality assurance strategy across all sprints to help ensure the system was stable, functional, and release ready.</a:t>
+            </a:r>
+          </a:p>
+          <a:p>
             <a:endParaRPr lang="en-US" dirty="0"/>
+          </a:p>
+          <a:p>
+            <a:r>
+              <a:rPr lang="en-US" dirty="0"/>
+              <a:t>Our testing approach used three layers of validation: frontend testing, backend/API testing, and end-to-end regression testing.</a:t>
+            </a:r>
+          </a:p>
+          <a:p>
+            <a:r>
+              <a:rPr lang="en-US" dirty="0"/>
+              <a:t>On the frontend, I built automated component and integration tests using Jest and React Testing Library, where we executed over </a:t>
+            </a:r>
+            <a:r>
+              <a:rPr lang="en-US" b="1" dirty="0"/>
+              <a:t>600 automated tests</a:t>
+            </a:r>
+            <a:r>
+              <a:rPr lang="en-US" dirty="0"/>
+              <a:t>, maintaining over </a:t>
+            </a:r>
+            <a:r>
+              <a:rPr lang="en-US" b="1" dirty="0"/>
+              <a:t>90% test coverage</a:t>
+            </a:r>
+            <a:r>
+              <a:rPr lang="en-US" dirty="0"/>
+              <a:t> while validating UI behavior, routing, and admin functionality.</a:t>
+            </a:r>
+          </a:p>
+          <a:p>
+            <a:r>
+              <a:rPr lang="en-US" dirty="0"/>
+              <a:t>For backend and API testing, I developed over </a:t>
+            </a:r>
+            <a:r>
+              <a:rPr lang="en-US" b="1" dirty="0"/>
+              <a:t>300 automated tests</a:t>
+            </a:r>
+            <a:r>
+              <a:rPr lang="en-US" dirty="0"/>
+              <a:t>, also with </a:t>
+            </a:r>
+            <a:r>
+              <a:rPr lang="en-US" b="1" dirty="0"/>
+              <a:t>90%+ coverage</a:t>
+            </a:r>
+            <a:r>
+              <a:rPr lang="en-US" dirty="0"/>
+              <a:t>, covering validation, role-based access control, inventory logic, reporting endpoints, and edge-case scenarios.</a:t>
+            </a:r>
+          </a:p>
+          <a:p>
+            <a:r>
+              <a:rPr lang="en-US" dirty="0"/>
+              <a:t>For end-to-end testing, I built and ran </a:t>
+            </a:r>
+            <a:r>
+              <a:rPr lang="en-US" b="1" dirty="0"/>
+              <a:t>166 Robot Framework tests</a:t>
+            </a:r>
+            <a:r>
+              <a:rPr lang="en-US" dirty="0"/>
+              <a:t>, validating critical customer workflows, admin regression scenarios, and full system interactions, with a </a:t>
+            </a:r>
+            <a:r>
+              <a:rPr lang="en-US" b="1" dirty="0"/>
+              <a:t>100 percent pass rate</a:t>
+            </a:r>
+            <a:r>
+              <a:rPr lang="en-US" dirty="0"/>
+              <a:t>.</a:t>
+            </a:r>
+          </a:p>
+          <a:p>
+            <a:r>
+              <a:rPr lang="en-US" dirty="0"/>
+              <a:t>In addition to automation, I led QA coordination by creating test plans, test cases, testing matrices, acceptance coverage reports, and supporting CI regression validation to help drive release readiness with no critical defects open.</a:t>
+            </a:r>
           </a:p>
         </p:txBody>
       </p:sp>
@@ -1641,31 +1843,9 @@
           <a:lstStyle/>
           <a:p>
             <a:r>
-              <a:rPr lang="en-US" sz="1200" b="1" i="0" kern="1200" dirty="0">
-                <a:solidFill>
-                  <a:schemeClr val="tx1"/>
-                </a:solidFill>
-                <a:effectLst/>
-                <a:latin typeface="+mn-lt"/>
-                <a:ea typeface="+mn-ea"/>
-                <a:cs typeface="+mn-cs"/>
-              </a:rPr>
-              <a:t>🟡 UP NEXT: </a:t>
-            </a:r>
-            <a:r>
-              <a:rPr lang="en-US" sz="1200" b="0" i="0" kern="1200" dirty="0">
-                <a:solidFill>
-                  <a:schemeClr val="tx1"/>
-                </a:solidFill>
-                <a:effectLst/>
-                <a:latin typeface="+mn-lt"/>
-                <a:ea typeface="+mn-ea"/>
-                <a:cs typeface="+mn-cs"/>
-              </a:rPr>
-              <a:t>How Agile brought forward our sprint structure (Serina)</a:t>
-            </a:r>
-          </a:p>
-          <a:p>
+              <a:rPr lang="en-US" dirty="0"/>
+              <a:t>🟡 SERINA (continues..)</a:t>
+            </a:r>
             <a:endParaRPr lang="en-US" sz="1200" b="0" i="0" kern="1200" dirty="0">
               <a:solidFill>
                 <a:schemeClr val="tx1"/>
@@ -1677,83 +1857,6 @@
             </a:endParaRPr>
           </a:p>
           <a:p>
-            <a:r>
-              <a:rPr lang="en-US" dirty="0"/>
-              <a:t>So, what is Orderly?</a:t>
-            </a:r>
-          </a:p>
-          <a:p>
-            <a:endParaRPr lang="en-US" dirty="0"/>
-          </a:p>
-          <a:p>
-            <a:r>
-              <a:rPr lang="en-US" dirty="0"/>
-              <a:t>At its core, Orderly is a </a:t>
-            </a:r>
-            <a:r>
-              <a:rPr lang="en-US" b="1" dirty="0"/>
-              <a:t>centralized web application</a:t>
-            </a:r>
-            <a:r>
-              <a:rPr lang="en-US" dirty="0"/>
-              <a:t> built to streamline operations for small to mid-sized businesses. </a:t>
-            </a:r>
-          </a:p>
-          <a:p>
-            <a:r>
-              <a:rPr lang="en-US" dirty="0"/>
-              <a:t>And the reason we built it comes down to a very real problem.</a:t>
-            </a:r>
-          </a:p>
-          <a:p>
-            <a:endParaRPr lang="en-US" dirty="0"/>
-          </a:p>
-          <a:p>
-            <a:r>
-              <a:rPr lang="en-US" dirty="0"/>
-              <a:t>Small business owners are managing orders on paper, tracking inventory in spreadsheets, and piecing together tools that were never meant to work together. The result is manual processes, missed orders, and zero real-time visibility into what's actually happening in their business.</a:t>
-            </a:r>
-          </a:p>
-          <a:p>
-            <a:endParaRPr lang="en-US" dirty="0"/>
-          </a:p>
-          <a:p>
-            <a:r>
-              <a:rPr lang="en-US" dirty="0"/>
-              <a:t>So we asked ourselves — what would it look like if all of that lived in one place?</a:t>
-            </a:r>
-          </a:p>
-          <a:p>
-            <a:endParaRPr lang="en-US" dirty="0"/>
-          </a:p>
-          <a:p>
-            <a:r>
-              <a:rPr lang="en-US" dirty="0"/>
-              <a:t>Orderly is the answer to that question. A flexible, self-service ordering and business management platform </a:t>
-            </a:r>
-          </a:p>
-          <a:p>
-            <a:r>
-              <a:rPr lang="en-US" dirty="0"/>
-              <a:t>— with a customer-facing storefront and a full business admin portal, built together from the ground up.</a:t>
-            </a:r>
-          </a:p>
-          <a:p>
-            <a:endParaRPr lang="en-US" dirty="0"/>
-          </a:p>
-          <a:p>
-            <a:r>
-              <a:rPr lang="en-US" dirty="0"/>
-              <a:t>Five sprints. Six team members. Over fifteen user features delivered.</a:t>
-            </a:r>
-          </a:p>
-          <a:p>
-            <a:r>
-              <a:rPr lang="en-US" dirty="0"/>
-              <a:t>And speaking of sprints — let me walk you through exactly how we got here.</a:t>
-            </a:r>
-          </a:p>
-          <a:p>
             <a:endParaRPr lang="en-US" sz="1200" b="0" i="0" kern="1200" dirty="0">
               <a:solidFill>
                 <a:schemeClr val="tx1"/>
@@ -1765,6 +1868,179 @@
             </a:endParaRPr>
           </a:p>
           <a:p>
+            <a:r>
+              <a:rPr lang="en-US" dirty="0"/>
+              <a:t>So — what exactly </a:t>
+            </a:r>
+            <a:r>
+              <a:rPr lang="en-US" i="1" dirty="0"/>
+              <a:t>is</a:t>
+            </a:r>
+            <a:r>
+              <a:rPr lang="en-US" dirty="0"/>
+              <a:t> “Orderly”?</a:t>
+            </a:r>
+          </a:p>
+          <a:p>
+            <a:endParaRPr lang="en-US" dirty="0"/>
+          </a:p>
+          <a:p>
+            <a:r>
+              <a:rPr lang="en-US" dirty="0"/>
+              <a:t>At the start of this semester…</a:t>
+            </a:r>
+          </a:p>
+          <a:p>
+            <a:r>
+              <a:rPr lang="en-US" dirty="0"/>
+              <a:t>our class was surveyed, grouped, and handed a Software Requirements Specification developed by a previous cohort. </a:t>
+            </a:r>
+          </a:p>
+          <a:p>
+            <a:r>
+              <a:rPr lang="en-US" dirty="0"/>
+              <a:t>Our challenge was simple: make it happen.</a:t>
+            </a:r>
+          </a:p>
+          <a:p>
+            <a:endParaRPr lang="en-US" dirty="0"/>
+          </a:p>
+          <a:p>
+            <a:r>
+              <a:rPr lang="en-US" dirty="0"/>
+              <a:t>What we were handed was a vision for a centralized web application — </a:t>
+            </a:r>
+          </a:p>
+          <a:p>
+            <a:r>
+              <a:rPr lang="en-US" dirty="0"/>
+              <a:t>one designed to solve a very real problem for small to mid-sized businesses. </a:t>
+            </a:r>
+          </a:p>
+          <a:p>
+            <a:endParaRPr lang="en-US" dirty="0"/>
+          </a:p>
+          <a:p>
+            <a:r>
+              <a:rPr lang="en-US" dirty="0"/>
+              <a:t>Owners managing orders on paper, tracking inventory in spreadsheets, juggling tools that were never meant to work together. </a:t>
+            </a:r>
+          </a:p>
+          <a:p>
+            <a:r>
+              <a:rPr lang="en-US" dirty="0"/>
+              <a:t>Manual processes, missed orders, no real-time visibility.</a:t>
+            </a:r>
+          </a:p>
+          <a:p>
+            <a:endParaRPr lang="en-US" dirty="0"/>
+          </a:p>
+          <a:p>
+            <a:r>
+              <a:rPr lang="en-US" dirty="0"/>
+              <a:t>Our job was to take that vision off the page and build it.</a:t>
+            </a:r>
+          </a:p>
+          <a:p>
+            <a:endParaRPr lang="en-US" dirty="0"/>
+          </a:p>
+          <a:p>
+            <a:r>
+              <a:rPr lang="en-US" dirty="0"/>
+              <a:t>The final result? Our application that stands today.. Orderly. </a:t>
+            </a:r>
+          </a:p>
+          <a:p>
+            <a:r>
+              <a:rPr lang="en-US" dirty="0"/>
+              <a:t>A </a:t>
+            </a:r>
+            <a:r>
+              <a:rPr lang="en-US" i="1" dirty="0"/>
+              <a:t>flexible</a:t>
+            </a:r>
+            <a:r>
+              <a:rPr lang="en-US" dirty="0"/>
+              <a:t>, </a:t>
+            </a:r>
+            <a:r>
+              <a:rPr lang="en-US" b="1" dirty="0"/>
+              <a:t>self-service..</a:t>
+            </a:r>
+            <a:r>
+              <a:rPr lang="en-US" dirty="0"/>
+              <a:t> ordering and business management platform — </a:t>
+            </a:r>
+          </a:p>
+          <a:p>
+            <a:r>
+              <a:rPr lang="en-US" dirty="0"/>
+              <a:t>with a customer-facing storefront </a:t>
+            </a:r>
+            <a:r>
+              <a:rPr lang="en-US" i="1" dirty="0"/>
+              <a:t>and</a:t>
+            </a:r>
+            <a:r>
+              <a:rPr lang="en-US" dirty="0"/>
+              <a:t> a full business admin portal. </a:t>
+            </a:r>
+            <a:r>
+              <a:rPr lang="en-US" b="1" dirty="0"/>
+              <a:t>Built</a:t>
+            </a:r>
+            <a:r>
+              <a:rPr lang="en-US" dirty="0"/>
+              <a:t>: from the </a:t>
+            </a:r>
+            <a:r>
+              <a:rPr lang="en-US" i="1" dirty="0"/>
+              <a:t>ground</a:t>
+            </a:r>
+            <a:r>
+              <a:rPr lang="en-US" dirty="0"/>
+              <a:t> up.</a:t>
+            </a:r>
+          </a:p>
+          <a:p>
+            <a:endParaRPr lang="en-US" dirty="0"/>
+          </a:p>
+          <a:p>
+            <a:r>
+              <a:rPr lang="en-US" b="1" dirty="0"/>
+              <a:t>Five</a:t>
+            </a:r>
+            <a:r>
+              <a:rPr lang="en-US" dirty="0"/>
+              <a:t> sprints. </a:t>
+            </a:r>
+            <a:r>
+              <a:rPr lang="en-US" b="1" dirty="0"/>
+              <a:t>Six</a:t>
+            </a:r>
+            <a:r>
+              <a:rPr lang="en-US" dirty="0"/>
+              <a:t> team members. And over fifteen user features </a:t>
+            </a:r>
+            <a:r>
+              <a:rPr lang="en-US" b="1" dirty="0"/>
+              <a:t>delivered</a:t>
+            </a:r>
+            <a:r>
+              <a:rPr lang="en-US" dirty="0"/>
+              <a:t>.</a:t>
+            </a:r>
+          </a:p>
+          <a:p>
+            <a:endParaRPr lang="en-US" dirty="0"/>
+          </a:p>
+          <a:p>
+            <a:r>
+              <a:rPr lang="en-US" dirty="0"/>
+              <a:t>Let me walk you through exactly how we got there.</a:t>
+            </a:r>
+          </a:p>
+          <a:p>
             <a:endParaRPr lang="en-US" sz="1200" b="0" i="0" kern="1200" dirty="0">
               <a:solidFill>
                 <a:schemeClr val="tx1"/>
@@ -1774,6 +2050,29 @@
               <a:ea typeface="+mn-ea"/>
               <a:cs typeface="+mn-cs"/>
             </a:endParaRPr>
+          </a:p>
+          <a:p>
+            <a:pPr marL="0" marR="0" lvl="0" indent="0" algn="l" defTabSz="914400" rtl="0" eaLnBrk="1" fontAlgn="auto" latinLnBrk="0" hangingPunct="1">
+              <a:lnSpc>
+                <a:spcPct val="100000"/>
+              </a:lnSpc>
+              <a:spcBef>
+                <a:spcPts val="0"/>
+              </a:spcBef>
+              <a:spcAft>
+                <a:spcPts val="0"/>
+              </a:spcAft>
+              <a:buClrTx/>
+              <a:buSzTx/>
+              <a:buFontTx/>
+              <a:buNone/>
+              <a:tabLst/>
+              <a:defRPr/>
+            </a:pPr>
+            <a:r>
+              <a:rPr lang="en-US" dirty="0"/>
+              <a:t>🎬 NEXT  SLIDE.. 😌 ⏭️</a:t>
+            </a:r>
           </a:p>
           <a:p>
             <a:endParaRPr lang="en-US" sz="1200" b="1" i="0" kern="1200" dirty="0">
@@ -2349,22 +2648,9 @@
           <a:lstStyle/>
           <a:p>
             <a:r>
-              <a:rPr lang="en-US" b="1" dirty="0"/>
-              <a:t>⏭️ UP NEXT: </a:t>
-            </a:r>
-            <a:r>
               <a:rPr lang="en-US" dirty="0"/>
-              <a:t>KIM (following slide)</a:t>
-            </a:r>
-          </a:p>
-          <a:p>
-            <a:r>
-              <a:rPr lang="en-US" dirty="0"/>
-              <a:t>To share what our team development delivered and how we scoped it all out!</a:t>
-            </a:r>
-          </a:p>
-          <a:p>
-            <a:endParaRPr lang="en-US" dirty="0"/>
+              <a:t>🟡 SERINA (continues..)</a:t>
+            </a:r>
           </a:p>
           <a:p>
             <a:r>
@@ -2374,12 +2660,6 @@
             <a:r>
               <a:rPr lang="en-US" dirty="0"/>
               <a:t>:</a:t>
-            </a:r>
-          </a:p>
-          <a:p>
-            <a:r>
-              <a:rPr lang="en-US" dirty="0"/>
-              <a:t>So let me walk you through how we actually built this.</a:t>
             </a:r>
           </a:p>
           <a:p>
@@ -2497,7 +2777,68 @@
           <a:p>
             <a:r>
               <a:rPr lang="en-US" dirty="0"/>
-              <a:t>I'll now hand it over to Kim, our Product Owner, to walk you through what we delivered.</a:t>
+              <a:t>I'll now hand it over to Kim, our Product Owner, to walk you through </a:t>
+            </a:r>
+            <a:r>
+              <a:rPr lang="en-US" b="1" dirty="0"/>
+              <a:t>what</a:t>
+            </a:r>
+            <a:r>
+              <a:rPr lang="en-US" dirty="0"/>
+              <a:t> we delivered and </a:t>
+            </a:r>
+            <a:r>
+              <a:rPr lang="en-US" b="1" i="1" dirty="0"/>
+              <a:t>how.. </a:t>
+            </a:r>
+            <a:r>
+              <a:rPr lang="en-US" dirty="0"/>
+              <a:t> we scoped it all out!</a:t>
+            </a:r>
+          </a:p>
+          <a:p>
+            <a:endParaRPr lang="en-US" dirty="0"/>
+          </a:p>
+          <a:p>
+            <a:r>
+              <a:rPr lang="en-US" dirty="0"/>
+              <a:t>Kim, if you could please 🙂‍↔️</a:t>
+            </a:r>
+          </a:p>
+          <a:p>
+            <a:endParaRPr lang="en-US" dirty="0"/>
+          </a:p>
+          <a:p>
+            <a:r>
+              <a:rPr lang="en-US" b="1" dirty="0"/>
+              <a:t>⏭️ UP NEXT: </a:t>
+            </a:r>
+            <a:r>
+              <a:rPr lang="en-US" dirty="0"/>
+              <a:t>KIM </a:t>
+            </a:r>
+          </a:p>
+          <a:p>
+            <a:pPr marL="0" marR="0" lvl="0" indent="0" algn="l" defTabSz="914400" rtl="0" eaLnBrk="1" fontAlgn="auto" latinLnBrk="0" hangingPunct="1">
+              <a:lnSpc>
+                <a:spcPct val="100000"/>
+              </a:lnSpc>
+              <a:spcBef>
+                <a:spcPts val="0"/>
+              </a:spcBef>
+              <a:spcAft>
+                <a:spcPts val="0"/>
+              </a:spcAft>
+              <a:buClrTx/>
+              <a:buSzTx/>
+              <a:buFontTx/>
+              <a:buNone/>
+              <a:tabLst/>
+              <a:defRPr/>
+            </a:pPr>
+            <a:r>
+              <a:rPr lang="en-US" dirty="0"/>
+              <a:t>🎬 NEXT  SLIDE.. 😌 ⏭️</a:t>
             </a:r>
           </a:p>
           <a:p>
@@ -2594,20 +2935,338 @@
           <a:p>
             <a:r>
               <a:rPr lang="en-US" dirty="0"/>
-              <a:t>🟡 Kim</a:t>
-            </a:r>
+              <a:t>🟡 Kim –</a:t>
+            </a:r>
+            <a:r>
+              <a:rPr lang="en-US" i="0" dirty="0"/>
+              <a:t>✨ You got this!</a:t>
+            </a:r>
+            <a:endParaRPr lang="en-US" i="1" dirty="0"/>
+          </a:p>
+          <a:p>
+            <a:endParaRPr lang="en-US" dirty="0"/>
           </a:p>
           <a:p>
             <a:r>
               <a:rPr lang="en-US" dirty="0"/>
-              <a:t>Note: These are the key features! Highlight them and let them shine through. Then… </a:t>
-            </a:r>
-          </a:p>
-          <a:p>
+              <a:t>Hi…! I’m Kim Mayo. ✨</a:t>
+            </a:r>
+          </a:p>
+          <a:p>
+            <a:r>
+              <a:rPr lang="en-US" b="1" dirty="0"/>
+              <a:t>Product Owner </a:t>
+            </a:r>
             <a:r>
               <a:rPr lang="en-US" dirty="0"/>
-              <a:t>Transition into the next slide to talk about the Epics that brought them to life plus BONUS stats</a:t>
-            </a:r>
+              <a:t>and </a:t>
+            </a:r>
+            <a:r>
+              <a:rPr lang="en-US" b="1" dirty="0"/>
+              <a:t>Full Stack </a:t>
+            </a:r>
+            <a:r>
+              <a:rPr lang="en-US" dirty="0"/>
+              <a:t>Developer for </a:t>
+            </a:r>
+            <a:r>
+              <a:rPr lang="en-US" b="1" dirty="0"/>
+              <a:t>Orderly</a:t>
+            </a:r>
+            <a:r>
+              <a:rPr lang="en-US" dirty="0"/>
+              <a:t>.</a:t>
+            </a:r>
+          </a:p>
+          <a:p>
+            <a:endParaRPr lang="en-US" dirty="0"/>
+          </a:p>
+          <a:p>
+            <a:r>
+              <a:rPr lang="en-US" dirty="0"/>
+              <a:t>.. Let’s take a look at some of the </a:t>
+            </a:r>
+            <a:r>
+              <a:rPr lang="en-US" i="1" dirty="0"/>
+              <a:t>key features </a:t>
+            </a:r>
+            <a:r>
+              <a:rPr lang="en-US" dirty="0"/>
+              <a:t>that make up its system..</a:t>
+            </a:r>
+          </a:p>
+          <a:p>
+            <a:endParaRPr lang="en-US" dirty="0"/>
+          </a:p>
+          <a:p>
+            <a:r>
+              <a:rPr lang="en-US" dirty="0"/>
+              <a:t>Orderly is designed around </a:t>
+            </a:r>
+            <a:r>
+              <a:rPr lang="en-US" b="1" dirty="0"/>
+              <a:t>two</a:t>
+            </a:r>
+            <a:r>
+              <a:rPr lang="en-US" dirty="0"/>
+              <a:t> main types of users: </a:t>
+            </a:r>
+          </a:p>
+          <a:p>
+            <a:r>
+              <a:rPr lang="en-US" b="1" dirty="0"/>
+              <a:t>customers</a:t>
+            </a:r>
+            <a:r>
+              <a:rPr lang="en-US" dirty="0"/>
+              <a:t> </a:t>
+            </a:r>
+            <a:r>
+              <a:rPr lang="en-US" i="1" dirty="0"/>
+              <a:t>and</a:t>
+            </a:r>
+            <a:r>
+              <a:rPr lang="en-US" dirty="0"/>
+              <a:t> </a:t>
+            </a:r>
+            <a:r>
+              <a:rPr lang="en-US" b="1" dirty="0"/>
+              <a:t>business users</a:t>
+            </a:r>
+            <a:r>
+              <a:rPr lang="en-US" dirty="0"/>
+              <a:t>.</a:t>
+            </a:r>
+          </a:p>
+          <a:p>
+            <a:endParaRPr lang="en-US" dirty="0"/>
+          </a:p>
+          <a:p>
+            <a:r>
+              <a:rPr lang="en-US" dirty="0"/>
+              <a:t>Orderly allows customers to </a:t>
+            </a:r>
+            <a:r>
+              <a:rPr lang="en-US" b="1" dirty="0"/>
+              <a:t>browse products</a:t>
+            </a:r>
+            <a:r>
+              <a:rPr lang="en-US" dirty="0"/>
+              <a:t>, </a:t>
+            </a:r>
+            <a:r>
+              <a:rPr lang="en-US" i="1" dirty="0"/>
+              <a:t>customize items</a:t>
+            </a:r>
+            <a:r>
+              <a:rPr lang="en-US" dirty="0"/>
+              <a:t>, and </a:t>
+            </a:r>
+            <a:r>
+              <a:rPr lang="en-US" b="1" dirty="0"/>
+              <a:t>place orders</a:t>
+            </a:r>
+            <a:r>
+              <a:rPr lang="en-US" dirty="0"/>
+              <a:t> with real-time updates.</a:t>
+            </a:r>
+          </a:p>
+          <a:p>
+            <a:endParaRPr lang="en-US" dirty="0"/>
+          </a:p>
+          <a:p>
+            <a:r>
+              <a:rPr lang="en-US" dirty="0"/>
+              <a:t>For business users, we built an </a:t>
+            </a:r>
+            <a:r>
+              <a:rPr lang="en-US" b="1" dirty="0"/>
+              <a:t>admin dashboard</a:t>
+            </a:r>
+            <a:r>
+              <a:rPr lang="en-US" dirty="0"/>
+              <a:t> that provides a </a:t>
+            </a:r>
+            <a:r>
+              <a:rPr lang="en-US" i="1" dirty="0"/>
+              <a:t>centralized view </a:t>
+            </a:r>
+            <a:r>
+              <a:rPr lang="en-US" dirty="0"/>
+              <a:t>of the system, with </a:t>
+            </a:r>
+            <a:r>
+              <a:rPr lang="en-US" b="1" dirty="0"/>
+              <a:t>role-based access</a:t>
+            </a:r>
+            <a:r>
+              <a:rPr lang="en-US" dirty="0"/>
+              <a:t> and </a:t>
+            </a:r>
+            <a:r>
+              <a:rPr lang="en-US" i="1" dirty="0"/>
+              <a:t>quick</a:t>
+            </a:r>
+            <a:r>
+              <a:rPr lang="en-US" dirty="0"/>
+              <a:t> </a:t>
+            </a:r>
+            <a:r>
+              <a:rPr lang="en-US" b="1" dirty="0"/>
+              <a:t>navigation</a:t>
+            </a:r>
+            <a:r>
+              <a:rPr lang="en-US" dirty="0"/>
+              <a:t>.</a:t>
+            </a:r>
+          </a:p>
+          <a:p>
+            <a:r>
+              <a:rPr lang="en-US" b="1" dirty="0"/>
+              <a:t>Admins</a:t>
+            </a:r>
+            <a:r>
+              <a:rPr lang="en-US" dirty="0"/>
+              <a:t> can </a:t>
+            </a:r>
+            <a:r>
+              <a:rPr lang="en-US" i="1" dirty="0"/>
+              <a:t>manage products</a:t>
+            </a:r>
+            <a:r>
+              <a:rPr lang="en-US" dirty="0"/>
+              <a:t>, </a:t>
+            </a:r>
+            <a:r>
+              <a:rPr lang="en-US" b="1" dirty="0"/>
+              <a:t>inventory</a:t>
+            </a:r>
+            <a:r>
+              <a:rPr lang="en-US" dirty="0"/>
+              <a:t>, </a:t>
+            </a:r>
+            <a:r>
+              <a:rPr lang="en-US" i="1" dirty="0"/>
+              <a:t>and..</a:t>
+            </a:r>
+            <a:r>
+              <a:rPr lang="en-US" dirty="0"/>
+              <a:t> orders, including </a:t>
+            </a:r>
+            <a:r>
+              <a:rPr lang="en-US" i="1" dirty="0"/>
+              <a:t>updating</a:t>
+            </a:r>
+            <a:r>
+              <a:rPr lang="en-US" dirty="0"/>
+              <a:t> </a:t>
+            </a:r>
+            <a:r>
+              <a:rPr lang="en-US" b="1" dirty="0"/>
+              <a:t>stock levels </a:t>
+            </a:r>
+            <a:r>
+              <a:rPr lang="en-US" dirty="0"/>
+              <a:t>and </a:t>
+            </a:r>
+            <a:r>
+              <a:rPr lang="en-US" i="1" dirty="0"/>
+              <a:t>tracking</a:t>
+            </a:r>
+            <a:r>
+              <a:rPr lang="en-US" dirty="0"/>
+              <a:t> </a:t>
+            </a:r>
+            <a:r>
+              <a:rPr lang="en-US" b="1" dirty="0"/>
+              <a:t>order activity</a:t>
+            </a:r>
+            <a:r>
+              <a:rPr lang="en-US" dirty="0"/>
+              <a:t>.</a:t>
+            </a:r>
+          </a:p>
+          <a:p>
+            <a:endParaRPr lang="en-US" dirty="0"/>
+          </a:p>
+          <a:p>
+            <a:r>
+              <a:rPr lang="en-US" dirty="0"/>
+              <a:t>We also included a sales dashboard </a:t>
+            </a:r>
+          </a:p>
+          <a:p>
+            <a:r>
+              <a:rPr lang="en-US" dirty="0"/>
+              <a:t>… to provide insights like </a:t>
+            </a:r>
+            <a:r>
+              <a:rPr lang="en-US" b="1" dirty="0"/>
+              <a:t>revenue and order trends</a:t>
+            </a:r>
+            <a:r>
+              <a:rPr lang="en-US" dirty="0"/>
+              <a:t>, helping to support </a:t>
+            </a:r>
+            <a:r>
+              <a:rPr lang="en-US" b="1" dirty="0"/>
+              <a:t>better</a:t>
+            </a:r>
+            <a:r>
+              <a:rPr lang="en-US" dirty="0"/>
+              <a:t> </a:t>
+            </a:r>
+            <a:r>
+              <a:rPr lang="en-US" i="1" dirty="0"/>
+              <a:t>business decisions ✨</a:t>
+            </a:r>
+          </a:p>
+          <a:p>
+            <a:endParaRPr lang="en-US" i="1" dirty="0"/>
+          </a:p>
+          <a:p>
+            <a:r>
+              <a:rPr lang="en-US" dirty="0"/>
+              <a:t>Now that we’ve looked at what </a:t>
+            </a:r>
+            <a:r>
+              <a:rPr lang="en-US" b="1" dirty="0"/>
+              <a:t>Orderly does from a </a:t>
+            </a:r>
+            <a:r>
+              <a:rPr lang="en-US" i="1" dirty="0"/>
+              <a:t>user perspective</a:t>
+            </a:r>
+            <a:r>
+              <a:rPr lang="en-US" dirty="0"/>
+              <a:t>,</a:t>
+            </a:r>
+          </a:p>
+          <a:p>
+            <a:r>
+              <a:rPr lang="en-US" dirty="0"/>
+              <a:t>let’s… talk about the </a:t>
+            </a:r>
+            <a:r>
+              <a:rPr lang="en-US" b="1" dirty="0"/>
+              <a:t>Epic planning </a:t>
+            </a:r>
+            <a:r>
+              <a:rPr lang="en-US" dirty="0"/>
+              <a:t>that brought them to life...!</a:t>
+            </a:r>
+          </a:p>
+          <a:p>
+            <a:endParaRPr lang="en-US" dirty="0"/>
+          </a:p>
+          <a:p>
+            <a:r>
+              <a:rPr lang="en-US" dirty="0"/>
+              <a:t>🎬 NEXT  SLIDE.. 😌 ⏭️</a:t>
+            </a:r>
+          </a:p>
+          <a:p>
+            <a:endParaRPr lang="en-US" dirty="0"/>
           </a:p>
         </p:txBody>
       </p:sp>
@@ -2718,22 +3377,269 @@
           <a:p>
             <a:r>
               <a:rPr lang="en-US" dirty="0"/>
-              <a:t>🟡 KIM:</a:t>
-            </a:r>
-            <a:br>
+              <a:t>🟡 KIM: -</a:t>
+            </a:r>
+            <a:r>
+              <a:rPr lang="en-US" i="1" dirty="0"/>
+              <a:t>breathe- 🍃</a:t>
+            </a:r>
+            <a:endParaRPr lang="en-US" dirty="0"/>
+          </a:p>
+          <a:p>
+            <a:endParaRPr lang="en-US" dirty="0"/>
+          </a:p>
+          <a:p>
+            <a:r>
               <a:rPr lang="en-US" dirty="0"/>
-            </a:br>
+              <a:t>Orderly is a </a:t>
+            </a:r>
+            <a:r>
+              <a:rPr lang="en-US" b="1" dirty="0"/>
+              <a:t>full-stack</a:t>
+            </a:r>
             <a:r>
               <a:rPr lang="en-US" dirty="0"/>
-              <a:t>The previous slide listed out the key features. </a:t>
-            </a:r>
-            <a:br>
+              <a:t> system..</a:t>
+            </a:r>
+          </a:p>
+          <a:p>
+            <a:r>
+              <a:rPr lang="en-US" i="1" dirty="0"/>
+              <a:t>Designed</a:t>
+            </a:r>
+            <a:r>
               <a:rPr lang="en-US" dirty="0"/>
-            </a:br>
+              <a:t> to be both: </a:t>
+            </a:r>
+            <a:r>
+              <a:rPr lang="en-US" b="1" dirty="0"/>
+              <a:t>flexible</a:t>
+            </a:r>
             <a:r>
               <a:rPr lang="en-US" dirty="0"/>
-              <a:t>Transition into this slide and focus on the Epics that were delivered + Bonus Stats ✨</a:t>
-            </a:r>
+              <a:t> </a:t>
+            </a:r>
+            <a:r>
+              <a:rPr lang="en-US" i="1" dirty="0"/>
+              <a:t>and</a:t>
+            </a:r>
+            <a:r>
+              <a:rPr lang="en-US" dirty="0"/>
+              <a:t> </a:t>
+            </a:r>
+            <a:r>
+              <a:rPr lang="en-US" b="1" dirty="0"/>
+              <a:t>scalable</a:t>
+            </a:r>
+            <a:r>
+              <a:rPr lang="en-US" dirty="0"/>
+              <a:t>.</a:t>
+            </a:r>
+          </a:p>
+          <a:p>
+            <a:endParaRPr lang="en-US" dirty="0"/>
+          </a:p>
+          <a:p>
+            <a:r>
+              <a:rPr lang="en-US" dirty="0"/>
+              <a:t>We worked across four major epics and delivered </a:t>
+            </a:r>
+            <a:r>
+              <a:rPr lang="en-US" b="1" dirty="0"/>
+              <a:t>over </a:t>
+            </a:r>
+            <a:r>
+              <a:rPr lang="en-US" dirty="0"/>
+              <a:t>25 user stories..</a:t>
+            </a:r>
+          </a:p>
+          <a:p>
+            <a:r>
+              <a:rPr lang="en-US" dirty="0"/>
+              <a:t>supporting both: </a:t>
+            </a:r>
+            <a:r>
+              <a:rPr lang="en-US" b="1" dirty="0"/>
+              <a:t>customers</a:t>
+            </a:r>
+            <a:r>
+              <a:rPr lang="en-US" dirty="0"/>
+              <a:t> </a:t>
+            </a:r>
+            <a:r>
+              <a:rPr lang="en-US" i="1" dirty="0"/>
+              <a:t>and</a:t>
+            </a:r>
+            <a:r>
+              <a:rPr lang="en-US" dirty="0"/>
+              <a:t> </a:t>
+            </a:r>
+            <a:r>
+              <a:rPr lang="en-US" b="1" dirty="0"/>
+              <a:t>business users</a:t>
+            </a:r>
+            <a:r>
+              <a:rPr lang="en-US" dirty="0"/>
+              <a:t>.</a:t>
+            </a:r>
+          </a:p>
+          <a:p>
+            <a:endParaRPr lang="en-US" dirty="0"/>
+          </a:p>
+          <a:p>
+            <a:r>
+              <a:rPr lang="en-US" dirty="0"/>
+              <a:t>As a team—</a:t>
+            </a:r>
+          </a:p>
+          <a:p>
+            <a:r>
+              <a:rPr lang="en-US" dirty="0"/>
+              <a:t>we made over 800 code commits</a:t>
+            </a:r>
+          </a:p>
+          <a:p>
+            <a:r>
+              <a:rPr lang="en-US" dirty="0"/>
+              <a:t>.. reflecting </a:t>
+            </a:r>
+            <a:r>
+              <a:rPr lang="en-US" i="1" dirty="0"/>
+              <a:t>strong collaboration </a:t>
+            </a:r>
+            <a:r>
+              <a:rPr lang="en-US" b="1" dirty="0"/>
+              <a:t>throughout</a:t>
+            </a:r>
+            <a:r>
+              <a:rPr lang="en-US" dirty="0"/>
+              <a:t> the project.</a:t>
+            </a:r>
+          </a:p>
+          <a:p>
+            <a:endParaRPr lang="en-US" dirty="0"/>
+          </a:p>
+          <a:p>
+            <a:r>
+              <a:rPr lang="en-US" dirty="0"/>
+              <a:t>We also developed </a:t>
+            </a:r>
+            <a:r>
+              <a:rPr lang="en-US" b="1" dirty="0"/>
+              <a:t>over 50</a:t>
+            </a:r>
+            <a:r>
+              <a:rPr lang="en-US" dirty="0"/>
+              <a:t> </a:t>
+            </a:r>
+            <a:r>
+              <a:rPr lang="en-US" i="0" dirty="0"/>
+              <a:t>API endpoints </a:t>
+            </a:r>
+            <a:r>
+              <a:rPr lang="en-US" b="1" dirty="0"/>
+              <a:t>and,</a:t>
+            </a:r>
+            <a:endParaRPr lang="en-US" dirty="0"/>
+          </a:p>
+          <a:p>
+            <a:r>
+              <a:rPr lang="en-US" dirty="0"/>
+              <a:t>supported them with automated testing to ensure system reliability.</a:t>
+            </a:r>
+          </a:p>
+          <a:p>
+            <a:endParaRPr lang="en-US" dirty="0"/>
+          </a:p>
+          <a:p>
+            <a:r>
+              <a:rPr lang="en-US" i="1" dirty="0"/>
+              <a:t>Finally</a:t>
+            </a:r>
+            <a:r>
+              <a:rPr lang="en-US" dirty="0"/>
+              <a:t>, </a:t>
+            </a:r>
+          </a:p>
+          <a:p>
+            <a:r>
+              <a:rPr lang="en-US" dirty="0"/>
+              <a:t>we maintained a living backlog.. to keep development </a:t>
+            </a:r>
+            <a:r>
+              <a:rPr lang="en-US" i="1" dirty="0"/>
+              <a:t>aligned…</a:t>
+            </a:r>
+            <a:r>
+              <a:rPr lang="en-US" dirty="0"/>
+              <a:t> and up to date.</a:t>
+            </a:r>
+          </a:p>
+          <a:p>
+            <a:r>
+              <a:rPr lang="en-US" dirty="0"/>
+              <a:t> </a:t>
+            </a:r>
+          </a:p>
+          <a:p>
+            <a:pPr marL="0" marR="0" lvl="0" indent="0" algn="l" defTabSz="914400" rtl="0" eaLnBrk="1" fontAlgn="auto" latinLnBrk="0" hangingPunct="1">
+              <a:lnSpc>
+                <a:spcPct val="100000"/>
+              </a:lnSpc>
+              <a:spcBef>
+                <a:spcPts val="0"/>
+              </a:spcBef>
+              <a:spcAft>
+                <a:spcPts val="0"/>
+              </a:spcAft>
+              <a:buClrTx/>
+              <a:buSzTx/>
+              <a:buFontTx/>
+              <a:buNone/>
+              <a:tabLst/>
+              <a:defRPr/>
+            </a:pPr>
+            <a:r>
+              <a:rPr lang="en-US" dirty="0"/>
+              <a:t>With that said, Let’s take a step back and </a:t>
+            </a:r>
+            <a:r>
+              <a:rPr lang="en-US" b="1" dirty="0"/>
+              <a:t>look </a:t>
+            </a:r>
+            <a:r>
+              <a:rPr lang="en-US" dirty="0"/>
+              <a:t>at the overall scope of the project… </a:t>
+            </a:r>
+          </a:p>
+          <a:p>
+            <a:endParaRPr lang="en-US" dirty="0"/>
+          </a:p>
+          <a:p>
+            <a:pPr marL="0" marR="0" lvl="0" indent="0" algn="l" defTabSz="914400" rtl="0" eaLnBrk="1" fontAlgn="auto" latinLnBrk="0" hangingPunct="1">
+              <a:lnSpc>
+                <a:spcPct val="100000"/>
+              </a:lnSpc>
+              <a:spcBef>
+                <a:spcPts val="0"/>
+              </a:spcBef>
+              <a:spcAft>
+                <a:spcPts val="0"/>
+              </a:spcAft>
+              <a:buClrTx/>
+              <a:buSzTx/>
+              <a:buFontTx/>
+              <a:buNone/>
+              <a:tabLst/>
+              <a:defRPr/>
+            </a:pPr>
+            <a:r>
+              <a:rPr lang="en-US" dirty="0"/>
+              <a:t>🎬 NEXT  SLIDE.. 😌 ⏭️</a:t>
+            </a:r>
+          </a:p>
+          <a:p>
+            <a:endParaRPr lang="en-US" dirty="0"/>
           </a:p>
         </p:txBody>
       </p:sp>
@@ -2849,13 +3755,223 @@
           <a:lstStyle/>
           <a:p>
             <a:r>
+              <a:rPr lang="en-US" dirty="0"/>
+              <a:t>🟡 KIM: </a:t>
+            </a:r>
+            <a:r>
+              <a:rPr lang="en-US" dirty="0">
+                <a:solidFill>
+                  <a:schemeClr val="accent3"/>
+                </a:solidFill>
+              </a:rPr>
+              <a:t>--one more to go!--</a:t>
+            </a:r>
+          </a:p>
+          <a:p>
+            <a:endParaRPr lang="en-US" b="0" dirty="0"/>
+          </a:p>
+          <a:p>
+            <a:r>
+              <a:rPr lang="en-US" dirty="0"/>
+              <a:t>To make </a:t>
+            </a:r>
+            <a:r>
               <a:rPr lang="en-US" b="1" dirty="0"/>
-              <a:t>🟡 Up Next: </a:t>
-            </a:r>
-            <a:r>
-              <a:rPr lang="en-US" b="0" dirty="0"/>
-              <a:t>What we are proud of (Kim continues..)</a:t>
-            </a:r>
+              <a:t>all</a:t>
+            </a:r>
+            <a:r>
+              <a:rPr lang="en-US" dirty="0"/>
+              <a:t> of that possible..</a:t>
+            </a:r>
+          </a:p>
+          <a:p>
+            <a:r>
+              <a:rPr lang="en-US" dirty="0"/>
+              <a:t>we had to be </a:t>
+            </a:r>
+            <a:r>
+              <a:rPr lang="en-US" i="1" dirty="0"/>
+              <a:t>very</a:t>
+            </a:r>
+            <a:r>
+              <a:rPr lang="en-US" dirty="0"/>
+              <a:t> intentional about </a:t>
+            </a:r>
+            <a:r>
+              <a:rPr lang="en-US" i="1" dirty="0"/>
+              <a:t>how</a:t>
+            </a:r>
+            <a:r>
+              <a:rPr lang="en-US" dirty="0"/>
+              <a:t> we managed scope and made our product decisions.</a:t>
+            </a:r>
+          </a:p>
+          <a:p>
+            <a:endParaRPr lang="en-US" dirty="0"/>
+          </a:p>
+          <a:p>
+            <a:r>
+              <a:rPr lang="en-US" dirty="0"/>
+              <a:t>We kept the project </a:t>
+            </a:r>
+            <a:r>
+              <a:rPr lang="en-US" b="1" dirty="0"/>
+              <a:t>focused</a:t>
+            </a:r>
+            <a:r>
+              <a:rPr lang="en-US" dirty="0"/>
+              <a:t> </a:t>
+            </a:r>
+            <a:r>
+              <a:rPr lang="en-US" i="1" dirty="0"/>
+              <a:t>and</a:t>
+            </a:r>
+            <a:r>
+              <a:rPr lang="en-US" dirty="0"/>
+              <a:t> </a:t>
+            </a:r>
+            <a:r>
+              <a:rPr lang="en-US" b="1" dirty="0"/>
+              <a:t>deliverable</a:t>
+            </a:r>
+            <a:r>
+              <a:rPr lang="en-US" dirty="0"/>
+              <a:t> </a:t>
+            </a:r>
+            <a:r>
+              <a:rPr lang="en-US" i="1" dirty="0"/>
+              <a:t>throughout development</a:t>
+            </a:r>
+            <a:r>
+              <a:rPr lang="en-US" dirty="0"/>
+              <a:t>.</a:t>
+            </a:r>
+          </a:p>
+          <a:p>
+            <a:r>
+              <a:rPr lang="en-US" dirty="0"/>
+              <a:t>We used Moscow to ensure critical features were completed </a:t>
+            </a:r>
+            <a:r>
+              <a:rPr lang="en-US" b="1" dirty="0"/>
+              <a:t>first</a:t>
+            </a:r>
+            <a:r>
+              <a:rPr lang="en-US" dirty="0"/>
+              <a:t>.</a:t>
+            </a:r>
+          </a:p>
+          <a:p>
+            <a:r>
+              <a:rPr lang="en-US" dirty="0"/>
+              <a:t>Also, we </a:t>
+            </a:r>
+            <a:r>
+              <a:rPr lang="en-US" dirty="0" err="1"/>
+              <a:t>followed..a</a:t>
+            </a:r>
+            <a:r>
+              <a:rPr lang="en-US" dirty="0"/>
+              <a:t> wave-based approach-- completing backend APIs </a:t>
+            </a:r>
+            <a:r>
+              <a:rPr lang="en-US" i="1" dirty="0"/>
+              <a:t>before</a:t>
+            </a:r>
+            <a:r>
+              <a:rPr lang="en-US" dirty="0"/>
+              <a:t> frontend integration to </a:t>
+            </a:r>
+            <a:r>
+              <a:rPr lang="en-US" b="0" i="1" dirty="0"/>
+              <a:t>reduce: </a:t>
+            </a:r>
+            <a:r>
+              <a:rPr lang="en-US" b="1" i="0" dirty="0"/>
+              <a:t>blockers</a:t>
+            </a:r>
+            <a:r>
+              <a:rPr lang="en-US" dirty="0"/>
+              <a:t>.</a:t>
+            </a:r>
+          </a:p>
+          <a:p>
+            <a:endParaRPr lang="en-US" dirty="0"/>
+          </a:p>
+          <a:p>
+            <a:r>
+              <a:rPr lang="en-US" dirty="0"/>
+              <a:t>We made sure </a:t>
+            </a:r>
+            <a:r>
+              <a:rPr lang="en-US" i="1" dirty="0"/>
+              <a:t>every</a:t>
+            </a:r>
+            <a:r>
+              <a:rPr lang="en-US" dirty="0"/>
+              <a:t> feature had </a:t>
+            </a:r>
+            <a:r>
+              <a:rPr lang="en-US" b="1" dirty="0"/>
+              <a:t>clear requirements </a:t>
+            </a:r>
+            <a:r>
+              <a:rPr lang="en-US" dirty="0"/>
+              <a:t>before development even began.</a:t>
+            </a:r>
+          </a:p>
+          <a:p>
+            <a:endParaRPr lang="en-US" dirty="0"/>
+          </a:p>
+          <a:p>
+            <a:r>
+              <a:rPr lang="en-US" dirty="0"/>
+              <a:t>.. These decisions helped us stay organized to deliver a </a:t>
+            </a:r>
+            <a:r>
+              <a:rPr lang="en-US" b="1" dirty="0"/>
+              <a:t>complete</a:t>
+            </a:r>
+            <a:r>
+              <a:rPr lang="en-US" dirty="0"/>
+              <a:t> </a:t>
+            </a:r>
+            <a:r>
+              <a:rPr lang="en-US" b="1" dirty="0"/>
+              <a:t>system</a:t>
+            </a:r>
+            <a:r>
+              <a:rPr lang="en-US" dirty="0"/>
+              <a:t>.</a:t>
+            </a:r>
+          </a:p>
+          <a:p>
+            <a:endParaRPr lang="en-US" b="1" dirty="0"/>
+          </a:p>
+          <a:p>
+            <a:pPr marL="0" marR="0" lvl="0" indent="0" algn="l" defTabSz="914400" rtl="0" eaLnBrk="1" fontAlgn="auto" latinLnBrk="0" hangingPunct="1">
+              <a:lnSpc>
+                <a:spcPct val="100000"/>
+              </a:lnSpc>
+              <a:spcBef>
+                <a:spcPts val="0"/>
+              </a:spcBef>
+              <a:spcAft>
+                <a:spcPts val="0"/>
+              </a:spcAft>
+              <a:buClrTx/>
+              <a:buSzTx/>
+              <a:buFontTx/>
+              <a:buNone/>
+              <a:tabLst/>
+              <a:defRPr/>
+            </a:pPr>
+            <a:r>
+              <a:rPr lang="en-US" dirty="0"/>
+              <a:t>🎬 NEXT  SLIDE.. 😌 ⏭️</a:t>
+            </a:r>
+          </a:p>
+          <a:p>
             <a:endParaRPr lang="en-US" b="1" dirty="0"/>
           </a:p>
         </p:txBody>
@@ -2954,6 +4070,58 @@
           <a:lstStyle/>
           <a:p>
             <a:r>
+              <a:rPr lang="en-US" dirty="0"/>
+              <a:t>🟡 KIM: </a:t>
+            </a:r>
+          </a:p>
+          <a:p>
+            <a:endParaRPr lang="en-US" b="1" dirty="0"/>
+          </a:p>
+          <a:p>
+            <a:r>
+              <a:rPr lang="en-US" dirty="0"/>
+              <a:t>Beyond how we built the system, we also want to highlight what stood out in how we worked as a team.</a:t>
+            </a:r>
+          </a:p>
+          <a:p>
+            <a:r>
+              <a:rPr lang="en-US" dirty="0"/>
+              <a:t>One of our biggest strengths was maintaining a clear API contract, which kept the frontend and backend aligned.</a:t>
+            </a:r>
+          </a:p>
+          <a:p>
+            <a:r>
+              <a:rPr lang="en-US" dirty="0"/>
+              <a:t>We also followed strong development practices, including code reviews and testing before merging changes.</a:t>
+            </a:r>
+          </a:p>
+          <a:p>
+            <a:r>
+              <a:rPr lang="en-US" dirty="0"/>
+              <a:t>Our team collaborated closely, supporting each other and adapting quickly when needed.</a:t>
+            </a:r>
+          </a:p>
+          <a:p>
+            <a:r>
+              <a:rPr lang="en-US" dirty="0"/>
+              <a:t>From a personal standpoint, I worked across both the backend and frontend, contributing to API development and frontend integration. I also helped ensure that features worked together end-to-end, focusing on connecting components and maintaining consistency across the system.</a:t>
+            </a:r>
+          </a:p>
+          <a:p>
+            <a:r>
+              <a:rPr lang="en-US" dirty="0"/>
+              <a:t>Overall, what we’re most proud of is that this idea became a reality—a complete platform with both a customer-facing interface and an admin portal that work together seamlessly.</a:t>
+            </a:r>
+            <a:endParaRPr lang="en-US" b="1" dirty="0"/>
+          </a:p>
+          <a:p>
+            <a:endParaRPr lang="en-US" b="1" dirty="0"/>
+          </a:p>
+          <a:p>
+            <a:endParaRPr lang="en-US" b="1" dirty="0"/>
+          </a:p>
+          <a:p>
+            <a:r>
               <a:rPr lang="en-US" b="1" dirty="0"/>
               <a:t>⏭️ Up Next: </a:t>
             </a:r>
@@ -2968,6 +4136,37 @@
               <a:rPr lang="en-US" b="0" dirty="0"/>
               <a:t>Transition with ”A Product that Actually feels like one…” into User Experience</a:t>
             </a:r>
+          </a:p>
+          <a:p>
+            <a:endParaRPr lang="en-US" b="0" dirty="0"/>
+          </a:p>
+          <a:p>
+            <a:endParaRPr lang="en-US" b="0" dirty="0"/>
+          </a:p>
+          <a:p>
+            <a:pPr marL="0" marR="0" lvl="0" indent="0" algn="l" defTabSz="914400" rtl="0" eaLnBrk="1" fontAlgn="auto" latinLnBrk="0" hangingPunct="1">
+              <a:lnSpc>
+                <a:spcPct val="100000"/>
+              </a:lnSpc>
+              <a:spcBef>
+                <a:spcPts val="0"/>
+              </a:spcBef>
+              <a:spcAft>
+                <a:spcPts val="0"/>
+              </a:spcAft>
+              <a:buClrTx/>
+              <a:buSzTx/>
+              <a:buFontTx/>
+              <a:buNone/>
+              <a:tabLst/>
+              <a:defRPr/>
+            </a:pPr>
+            <a:r>
+              <a:rPr lang="en-US" dirty="0"/>
+              <a:t>🎬 NEXT  SLIDE.. 😌 ⏭️</a:t>
+            </a:r>
+          </a:p>
+          <a:p>
             <a:endParaRPr lang="en-US" b="1" dirty="0"/>
           </a:p>
         </p:txBody>
@@ -11009,7 +12208,13 @@
       </p:grpSpPr>
       <p:sp>
         <p:nvSpPr>
-          <p:cNvPr id="5" name="Shape 3"/>
+          <p:cNvPr id="2" name="Shape 3">
+            <a:extLst>
+              <a:ext uri="{FF2B5EF4-FFF2-40B4-BE49-F238E27FC236}">
+                <a16:creationId xmlns:a16="http://schemas.microsoft.com/office/drawing/2014/main" id="{F49C1F25-058A-FA60-9447-591175FD1CAF}"/>
+              </a:ext>
+            </a:extLst>
+          </p:cNvPr>
           <p:cNvSpPr/>
           <p:nvPr/>
         </p:nvSpPr>
@@ -11048,7 +12253,13 @@
       </p:sp>
       <p:sp>
         <p:nvSpPr>
-          <p:cNvPr id="6" name="Shape 4"/>
+          <p:cNvPr id="3" name="Shape 4">
+            <a:extLst>
+              <a:ext uri="{FF2B5EF4-FFF2-40B4-BE49-F238E27FC236}">
+                <a16:creationId xmlns:a16="http://schemas.microsoft.com/office/drawing/2014/main" id="{64B1D373-E15C-7AFC-6EBB-9BD2546B576E}"/>
+              </a:ext>
+            </a:extLst>
+          </p:cNvPr>
           <p:cNvSpPr/>
           <p:nvPr/>
         </p:nvSpPr>
@@ -11080,7 +12291,13 @@
       </p:sp>
       <p:pic>
         <p:nvPicPr>
-          <p:cNvPr id="7" name="Image 0" descr="preencoded.png"/>
+          <p:cNvPr id="4" name="Image 0" descr="preencoded.png">
+            <a:extLst>
+              <a:ext uri="{FF2B5EF4-FFF2-40B4-BE49-F238E27FC236}">
+                <a16:creationId xmlns:a16="http://schemas.microsoft.com/office/drawing/2014/main" id="{598252FF-5FFC-8096-A8A6-69EA63847B8D}"/>
+              </a:ext>
+            </a:extLst>
+          </p:cNvPr>
           <p:cNvPicPr>
             <a:picLocks noChangeAspect="1"/>
           </p:cNvPicPr>
@@ -11104,7 +12321,13 @@
       </p:pic>
       <p:sp>
         <p:nvSpPr>
-          <p:cNvPr id="8" name="Text 5"/>
+          <p:cNvPr id="28" name="Text 5">
+            <a:extLst>
+              <a:ext uri="{FF2B5EF4-FFF2-40B4-BE49-F238E27FC236}">
+                <a16:creationId xmlns:a16="http://schemas.microsoft.com/office/drawing/2014/main" id="{9D4AE993-7C31-7A57-642C-9B1E6E83F744}"/>
+              </a:ext>
+            </a:extLst>
+          </p:cNvPr>
           <p:cNvSpPr/>
           <p:nvPr/>
         </p:nvSpPr>
@@ -11135,7 +12358,7 @@
                 <a:ea typeface="Calibri" pitchFamily="34" charset="-122"/>
                 <a:cs typeface="Calibri" pitchFamily="34" charset="-120"/>
               </a:rPr>
-              <a:t>The Challenge</a:t>
+              <a:t>Issue Discovered</a:t>
             </a:r>
             <a:endParaRPr lang="en-US" sz="1100" dirty="0"/>
           </a:p>
@@ -11143,7 +12366,13 @@
       </p:sp>
       <p:sp>
         <p:nvSpPr>
-          <p:cNvPr id="9" name="Text 6"/>
+          <p:cNvPr id="29" name="Text 6">
+            <a:extLst>
+              <a:ext uri="{FF2B5EF4-FFF2-40B4-BE49-F238E27FC236}">
+                <a16:creationId xmlns:a16="http://schemas.microsoft.com/office/drawing/2014/main" id="{9FB6D8C4-9FD3-6F27-81C3-1D4BFDCFBEC8}"/>
+              </a:ext>
+            </a:extLst>
+          </p:cNvPr>
           <p:cNvSpPr/>
           <p:nvPr/>
         </p:nvSpPr>
@@ -11174,10 +12403,22 @@
                 <a:ea typeface="Calibri" pitchFamily="34" charset="-122"/>
                 <a:cs typeface="Calibri" pitchFamily="34" charset="-120"/>
               </a:rPr>
-              <a:t>Feature Area / Test Name
-</a:t>
+              <a:t>Defect Summary</a:t>
             </a:r>
             <a:endParaRPr lang="en-US" sz="1000" dirty="0"/>
+          </a:p>
+          <a:p>
+            <a:pPr marL="0" indent="0">
+              <a:buNone/>
+            </a:pPr>
+            <a:endParaRPr lang="en-US" sz="1000" dirty="0">
+              <a:solidFill>
+                <a:srgbClr val="64748B"/>
+              </a:solidFill>
+              <a:latin typeface="Calibri" pitchFamily="34" charset="0"/>
+              <a:ea typeface="Calibri" pitchFamily="34" charset="-122"/>
+              <a:cs typeface="Calibri" pitchFamily="34" charset="-120"/>
+            </a:endParaRPr>
           </a:p>
           <a:p>
             <a:pPr marL="0" indent="0">
@@ -11192,15 +12433,49 @@
                 <a:ea typeface="Calibri" pitchFamily="34" charset="-122"/>
                 <a:cs typeface="Calibri" pitchFamily="34" charset="-120"/>
               </a:rPr>
-              <a:t>[Placeholder: Describe what this test was validating — e.g., role-based access control on admin routes, or end-to-end order submission flow.]</a:t>
-            </a:r>
-            <a:endParaRPr lang="en-US" sz="1000" dirty="0"/>
-          </a:p>
-        </p:txBody>
-      </p:sp>
-      <p:sp>
-        <p:nvSpPr>
-          <p:cNvPr id="10" name="Shape 7"/>
+              <a:t>During Admin RBAC testing, QA found logged-out users could access /admin/products instead of being redirected to login.</a:t>
+            </a:r>
+          </a:p>
+          <a:p>
+            <a:pPr marL="0" indent="0">
+              <a:buNone/>
+            </a:pPr>
+            <a:endParaRPr lang="en-US" sz="1000" dirty="0">
+              <a:solidFill>
+                <a:srgbClr val="64748B"/>
+              </a:solidFill>
+              <a:latin typeface="Calibri" pitchFamily="34" charset="0"/>
+              <a:ea typeface="Calibri" pitchFamily="34" charset="-122"/>
+              <a:cs typeface="Calibri" pitchFamily="34" charset="-120"/>
+            </a:endParaRPr>
+          </a:p>
+          <a:p>
+            <a:pPr marL="0" indent="0">
+              <a:buNone/>
+            </a:pPr>
+            <a:r>
+              <a:rPr lang="en-US" sz="1000" dirty="0">
+                <a:solidFill>
+                  <a:srgbClr val="64748B"/>
+                </a:solidFill>
+                <a:latin typeface="Calibri" pitchFamily="34" charset="0"/>
+                <a:ea typeface="Calibri" pitchFamily="34" charset="-122"/>
+                <a:cs typeface="Calibri" pitchFamily="34" charset="-120"/>
+              </a:rPr>
+              <a:t>A high-severity bug report was created with reproduction steps, expected vs actual behavior, and security impact.</a:t>
+            </a:r>
+          </a:p>
+        </p:txBody>
+      </p:sp>
+      <p:sp>
+        <p:nvSpPr>
+          <p:cNvPr id="30" name="Shape 7">
+            <a:extLst>
+              <a:ext uri="{FF2B5EF4-FFF2-40B4-BE49-F238E27FC236}">
+                <a16:creationId xmlns:a16="http://schemas.microsoft.com/office/drawing/2014/main" id="{1B270BB0-45AC-1B2A-2BD8-2AB04962D9D4}"/>
+              </a:ext>
+            </a:extLst>
+          </p:cNvPr>
           <p:cNvSpPr/>
           <p:nvPr/>
         </p:nvSpPr>
@@ -11239,7 +12514,13 @@
       </p:sp>
       <p:sp>
         <p:nvSpPr>
-          <p:cNvPr id="11" name="Shape 8"/>
+          <p:cNvPr id="31" name="Shape 8">
+            <a:extLst>
+              <a:ext uri="{FF2B5EF4-FFF2-40B4-BE49-F238E27FC236}">
+                <a16:creationId xmlns:a16="http://schemas.microsoft.com/office/drawing/2014/main" id="{F4DF9DEA-3D91-70D9-747D-235B9118308B}"/>
+              </a:ext>
+            </a:extLst>
+          </p:cNvPr>
           <p:cNvSpPr/>
           <p:nvPr/>
         </p:nvSpPr>
@@ -11271,7 +12552,13 @@
       </p:sp>
       <p:pic>
         <p:nvPicPr>
-          <p:cNvPr id="12" name="Image 1" descr="preencoded.png"/>
+          <p:cNvPr id="32" name="Image 1" descr="preencoded.png">
+            <a:extLst>
+              <a:ext uri="{FF2B5EF4-FFF2-40B4-BE49-F238E27FC236}">
+                <a16:creationId xmlns:a16="http://schemas.microsoft.com/office/drawing/2014/main" id="{9A042BE0-FDB7-72CC-4802-2D6903EF17B3}"/>
+              </a:ext>
+            </a:extLst>
+          </p:cNvPr>
           <p:cNvPicPr>
             <a:picLocks noChangeAspect="1"/>
           </p:cNvPicPr>
@@ -11295,7 +12582,13 @@
       </p:pic>
       <p:sp>
         <p:nvSpPr>
-          <p:cNvPr id="13" name="Text 9"/>
+          <p:cNvPr id="33" name="Text 9">
+            <a:extLst>
+              <a:ext uri="{FF2B5EF4-FFF2-40B4-BE49-F238E27FC236}">
+                <a16:creationId xmlns:a16="http://schemas.microsoft.com/office/drawing/2014/main" id="{64185BED-4976-0511-4611-335713A4BAEB}"/>
+              </a:ext>
+            </a:extLst>
+          </p:cNvPr>
           <p:cNvSpPr/>
           <p:nvPr/>
         </p:nvSpPr>
@@ -11326,7 +12619,7 @@
                 <a:ea typeface="Calibri" pitchFamily="34" charset="-122"/>
                 <a:cs typeface="Calibri" pitchFamily="34" charset="-120"/>
               </a:rPr>
-              <a:t>How It Was Identified</a:t>
+              <a:t>Detection &amp; Validation</a:t>
             </a:r>
             <a:endParaRPr lang="en-US" sz="1100" dirty="0"/>
           </a:p>
@@ -11334,7 +12627,13 @@
       </p:sp>
       <p:sp>
         <p:nvSpPr>
-          <p:cNvPr id="14" name="Text 10"/>
+          <p:cNvPr id="34" name="Text 10">
+            <a:extLst>
+              <a:ext uri="{FF2B5EF4-FFF2-40B4-BE49-F238E27FC236}">
+                <a16:creationId xmlns:a16="http://schemas.microsoft.com/office/drawing/2014/main" id="{D4782811-6061-26C2-C14A-DFC6578F4C33}"/>
+              </a:ext>
+            </a:extLst>
+          </p:cNvPr>
           <p:cNvSpPr/>
           <p:nvPr/>
         </p:nvSpPr>
@@ -11365,7 +12664,7 @@
                 <a:ea typeface="Calibri" pitchFamily="34" charset="-122"/>
                 <a:cs typeface="Calibri" pitchFamily="34" charset="-120"/>
               </a:rPr>
-              <a:t>Detection Method
+              <a:t>Validation Approach
 </a:t>
             </a:r>
             <a:endParaRPr lang="en-US" sz="1000" dirty="0"/>
@@ -11383,7 +12682,36 @@
                 <a:ea typeface="Calibri" pitchFamily="34" charset="-122"/>
                 <a:cs typeface="Calibri" pitchFamily="34" charset="-120"/>
               </a:rPr>
-              <a:t>[Placeholder: How was this caught? Automated test failure, manual QA pass, CI regression run, code review flag? 1–2 sentences on the moment of discovery.]</a:t>
+              <a:t>The issue was traced to route protection and access control logic.</a:t>
+            </a:r>
+          </a:p>
+          <a:p>
+            <a:pPr marL="0" indent="0">
+              <a:buNone/>
+            </a:pPr>
+            <a:endParaRPr lang="en-US" sz="1000" dirty="0">
+              <a:solidFill>
+                <a:srgbClr val="64748B"/>
+              </a:solidFill>
+              <a:latin typeface="Calibri" pitchFamily="34" charset="0"/>
+              <a:ea typeface="Calibri" pitchFamily="34" charset="-122"/>
+              <a:cs typeface="Calibri" pitchFamily="34" charset="-120"/>
+            </a:endParaRPr>
+          </a:p>
+          <a:p>
+            <a:pPr marL="0" indent="0">
+              <a:buNone/>
+            </a:pPr>
+            <a:r>
+              <a:rPr lang="en-US" sz="1000" dirty="0">
+                <a:solidFill>
+                  <a:srgbClr val="64748B"/>
+                </a:solidFill>
+                <a:latin typeface="Calibri" pitchFamily="34" charset="0"/>
+                <a:ea typeface="Calibri" pitchFamily="34" charset="-122"/>
+                <a:cs typeface="Calibri" pitchFamily="34" charset="-120"/>
+              </a:rPr>
+              <a:t>After the fix was implemented, it was validated through manual retesting and automated regression testing across unauthorized access scenarios.</a:t>
             </a:r>
             <a:endParaRPr lang="en-US" sz="1000" dirty="0"/>
           </a:p>
@@ -11391,7 +12719,13 @@
       </p:sp>
       <p:sp>
         <p:nvSpPr>
-          <p:cNvPr id="15" name="Shape 11"/>
+          <p:cNvPr id="35" name="Shape 11">
+            <a:extLst>
+              <a:ext uri="{FF2B5EF4-FFF2-40B4-BE49-F238E27FC236}">
+                <a16:creationId xmlns:a16="http://schemas.microsoft.com/office/drawing/2014/main" id="{513445BB-F97E-28E1-58BD-A1BB25BCD55E}"/>
+              </a:ext>
+            </a:extLst>
+          </p:cNvPr>
           <p:cNvSpPr/>
           <p:nvPr/>
         </p:nvSpPr>
@@ -11430,7 +12764,13 @@
       </p:sp>
       <p:sp>
         <p:nvSpPr>
-          <p:cNvPr id="16" name="Shape 12"/>
+          <p:cNvPr id="36" name="Shape 12">
+            <a:extLst>
+              <a:ext uri="{FF2B5EF4-FFF2-40B4-BE49-F238E27FC236}">
+                <a16:creationId xmlns:a16="http://schemas.microsoft.com/office/drawing/2014/main" id="{576FF371-7533-3EFA-9146-2F9C09E10D47}"/>
+              </a:ext>
+            </a:extLst>
+          </p:cNvPr>
           <p:cNvSpPr/>
           <p:nvPr/>
         </p:nvSpPr>
@@ -11456,13 +12796,19 @@
           <a:bodyPr/>
           <a:lstStyle/>
           <a:p>
-            <a:endParaRPr lang="en-US"/>
+            <a:endParaRPr lang="en-US" dirty="0"/>
           </a:p>
         </p:txBody>
       </p:sp>
       <p:pic>
         <p:nvPicPr>
-          <p:cNvPr id="17" name="Image 2" descr="preencoded.png"/>
+          <p:cNvPr id="37" name="Image 2" descr="preencoded.png">
+            <a:extLst>
+              <a:ext uri="{FF2B5EF4-FFF2-40B4-BE49-F238E27FC236}">
+                <a16:creationId xmlns:a16="http://schemas.microsoft.com/office/drawing/2014/main" id="{03DD63C0-768C-3BDE-D2FF-B43E0505E9F9}"/>
+              </a:ext>
+            </a:extLst>
+          </p:cNvPr>
           <p:cNvPicPr>
             <a:picLocks noChangeAspect="1"/>
           </p:cNvPicPr>
@@ -11486,7 +12832,13 @@
       </p:pic>
       <p:sp>
         <p:nvSpPr>
-          <p:cNvPr id="18" name="Text 13"/>
+          <p:cNvPr id="38" name="Text 13">
+            <a:extLst>
+              <a:ext uri="{FF2B5EF4-FFF2-40B4-BE49-F238E27FC236}">
+                <a16:creationId xmlns:a16="http://schemas.microsoft.com/office/drawing/2014/main" id="{F516D6C4-73F6-8776-FE15-C18B6C19FDEA}"/>
+              </a:ext>
+            </a:extLst>
+          </p:cNvPr>
           <p:cNvSpPr/>
           <p:nvPr/>
         </p:nvSpPr>
@@ -11517,7 +12869,7 @@
                 <a:ea typeface="Calibri" pitchFamily="34" charset="-122"/>
                 <a:cs typeface="Calibri" pitchFamily="34" charset="-120"/>
               </a:rPr>
-              <a:t>Resolution &amp; Outcome</a:t>
+              <a:t>Resolution &amp; Impact</a:t>
             </a:r>
             <a:endParaRPr lang="en-US" sz="1100" dirty="0"/>
           </a:p>
@@ -11525,7 +12877,13 @@
       </p:sp>
       <p:sp>
         <p:nvSpPr>
-          <p:cNvPr id="19" name="Text 14"/>
+          <p:cNvPr id="39" name="Text 14">
+            <a:extLst>
+              <a:ext uri="{FF2B5EF4-FFF2-40B4-BE49-F238E27FC236}">
+                <a16:creationId xmlns:a16="http://schemas.microsoft.com/office/drawing/2014/main" id="{9893E8BF-D703-D8D6-2F2C-3D7C4D3A0B65}"/>
+              </a:ext>
+            </a:extLst>
+          </p:cNvPr>
           <p:cNvSpPr/>
           <p:nvPr/>
         </p:nvSpPr>
@@ -11556,7 +12914,7 @@
                 <a:ea typeface="Calibri" pitchFamily="34" charset="-122"/>
                 <a:cs typeface="Calibri" pitchFamily="34" charset="-120"/>
               </a:rPr>
-              <a:t>Team Collaboration
+              <a:t>Outcome &amp; Coverage
 </a:t>
             </a:r>
             <a:endParaRPr lang="en-US" sz="1000" dirty="0"/>
@@ -11574,7 +12932,36 @@
                 <a:ea typeface="Calibri" pitchFamily="34" charset="-122"/>
                 <a:cs typeface="Calibri" pitchFamily="34" charset="-120"/>
               </a:rPr>
-              <a:t>[Placeholder: Who flagged it, who fixed it, how it was verified. E.g., 'Kenny identified the failure, Tristin traced it to the API layer, Kim deployed the fix — retested and confirmed passing.']</a:t>
+              <a:t>Unauthorized access was blocked and RBAC behavior was corrected.</a:t>
+            </a:r>
+          </a:p>
+          <a:p>
+            <a:pPr marL="0" indent="0">
+              <a:buNone/>
+            </a:pPr>
+            <a:endParaRPr lang="en-US" sz="1000" dirty="0">
+              <a:solidFill>
+                <a:srgbClr val="64748B"/>
+              </a:solidFill>
+              <a:latin typeface="Calibri" pitchFamily="34" charset="0"/>
+              <a:ea typeface="Calibri" pitchFamily="34" charset="-122"/>
+              <a:cs typeface="Calibri" pitchFamily="34" charset="-120"/>
+            </a:endParaRPr>
+          </a:p>
+          <a:p>
+            <a:pPr marL="0" indent="0">
+              <a:buNone/>
+            </a:pPr>
+            <a:r>
+              <a:rPr lang="en-US" sz="1000" dirty="0">
+                <a:solidFill>
+                  <a:srgbClr val="64748B"/>
+                </a:solidFill>
+                <a:latin typeface="Calibri" pitchFamily="34" charset="0"/>
+                <a:ea typeface="Calibri" pitchFamily="34" charset="-122"/>
+                <a:cs typeface="Calibri" pitchFamily="34" charset="-120"/>
+              </a:rPr>
+              <a:t>Regression coverage and related test cases were added to prevent recurrence and strengthen admin security validation.</a:t>
             </a:r>
             <a:endParaRPr lang="en-US" sz="1000" dirty="0"/>
           </a:p>
@@ -11582,7 +12969,13 @@
       </p:sp>
       <p:sp>
         <p:nvSpPr>
-          <p:cNvPr id="20" name="Shape 15"/>
+          <p:cNvPr id="40" name="Shape 15">
+            <a:extLst>
+              <a:ext uri="{FF2B5EF4-FFF2-40B4-BE49-F238E27FC236}">
+                <a16:creationId xmlns:a16="http://schemas.microsoft.com/office/drawing/2014/main" id="{5EACD248-E07A-DA59-CDD8-617291950ADF}"/>
+              </a:ext>
+            </a:extLst>
+          </p:cNvPr>
           <p:cNvSpPr/>
           <p:nvPr/>
         </p:nvSpPr>
@@ -11614,7 +13007,13 @@
       </p:sp>
       <p:sp>
         <p:nvSpPr>
-          <p:cNvPr id="21" name="Shape 16"/>
+          <p:cNvPr id="41" name="Shape 16">
+            <a:extLst>
+              <a:ext uri="{FF2B5EF4-FFF2-40B4-BE49-F238E27FC236}">
+                <a16:creationId xmlns:a16="http://schemas.microsoft.com/office/drawing/2014/main" id="{06077A62-C240-C626-EB9A-85D6D7FB7359}"/>
+              </a:ext>
+            </a:extLst>
+          </p:cNvPr>
           <p:cNvSpPr/>
           <p:nvPr/>
         </p:nvSpPr>
@@ -11646,7 +13045,13 @@
       </p:sp>
       <p:pic>
         <p:nvPicPr>
-          <p:cNvPr id="22" name="Image 3" descr="preencoded.png"/>
+          <p:cNvPr id="42" name="Image 3" descr="preencoded.png">
+            <a:extLst>
+              <a:ext uri="{FF2B5EF4-FFF2-40B4-BE49-F238E27FC236}">
+                <a16:creationId xmlns:a16="http://schemas.microsoft.com/office/drawing/2014/main" id="{9641A18C-4DE2-E9C3-FC54-11B47AC046F3}"/>
+              </a:ext>
+            </a:extLst>
+          </p:cNvPr>
           <p:cNvPicPr>
             <a:picLocks noChangeAspect="1"/>
           </p:cNvPicPr>
@@ -11670,7 +13075,13 @@
       </p:pic>
       <p:sp>
         <p:nvSpPr>
-          <p:cNvPr id="23" name="Text 17"/>
+          <p:cNvPr id="43" name="Text 17">
+            <a:extLst>
+              <a:ext uri="{FF2B5EF4-FFF2-40B4-BE49-F238E27FC236}">
+                <a16:creationId xmlns:a16="http://schemas.microsoft.com/office/drawing/2014/main" id="{6298B990-AD46-E759-765E-76B87E03ED5A}"/>
+              </a:ext>
+            </a:extLst>
+          </p:cNvPr>
           <p:cNvSpPr/>
           <p:nvPr/>
         </p:nvSpPr>
@@ -11701,10 +13112,21 @@
                 <a:ea typeface="Calibri" pitchFamily="34" charset="-122"/>
                 <a:cs typeface="Calibri" pitchFamily="34" charset="-120"/>
               </a:rPr>
-              <a:t>[ Key Highlight Place Holder ]
-</a:t>
-            </a:r>
-            <a:endParaRPr lang="en-US" sz="1100" dirty="0"/>
+              <a:t>Key QA Highlight: Security and Regression Validation</a:t>
+            </a:r>
+          </a:p>
+          <a:p>
+            <a:pPr marL="0" indent="0">
+              <a:buNone/>
+            </a:pPr>
+            <a:endParaRPr lang="en-US" sz="1100" b="1" i="1" dirty="0">
+              <a:solidFill>
+                <a:srgbClr val="FFFFFF"/>
+              </a:solidFill>
+              <a:latin typeface="Calibri" pitchFamily="34" charset="0"/>
+              <a:ea typeface="Calibri" pitchFamily="34" charset="-122"/>
+              <a:cs typeface="Calibri" pitchFamily="34" charset="-120"/>
+            </a:endParaRPr>
           </a:p>
           <a:p>
             <a:pPr marL="0" indent="0">
@@ -11719,51 +13141,79 @@
                 <a:ea typeface="Calibri" pitchFamily="34" charset="-122"/>
                 <a:cs typeface="Calibri" pitchFamily="34" charset="-120"/>
               </a:rPr>
-              <a:t>"Quality assurance isn't just about coverage numbers — it's about catching the right things at the right time. [This sprint/This test] is an example of the team's process working exactly as intended."</a:t>
-            </a:r>
-            <a:endParaRPr lang="en-US" sz="1100" dirty="0"/>
-          </a:p>
-        </p:txBody>
-      </p:sp>
-      <p:sp>
-        <p:nvSpPr>
-          <p:cNvPr id="24" name="Text 0">
-            <a:extLst>
-              <a:ext uri="{FF2B5EF4-FFF2-40B4-BE49-F238E27FC236}">
-                <a16:creationId xmlns:a16="http://schemas.microsoft.com/office/drawing/2014/main" id="{CE4396FD-BDF5-670C-F4B3-30360F218813}"/>
-              </a:ext>
-            </a:extLst>
-          </p:cNvPr>
-          <p:cNvSpPr/>
-          <p:nvPr/>
-        </p:nvSpPr>
-        <p:spPr>
-          <a:xfrm>
-            <a:off x="457200" y="164592"/>
-            <a:ext cx="8229600" cy="256032"/>
-          </a:xfrm>
-          <a:prstGeom prst="rect">
-            <a:avLst/>
-          </a:prstGeom>
-          <a:noFill/>
-          <a:ln/>
-        </p:spPr>
-        <p:txBody>
-          <a:bodyPr wrap="square" lIns="0" tIns="0" rIns="0" bIns="0" rtlCol="0" anchor="ctr"/>
-          <a:lstStyle/>
-          <a:p>
-            <a:pPr marL="0" indent="0" algn="l">
-              <a:buNone/>
-            </a:pPr>
-            <a:r>
-              <a:rPr lang="en-US" sz="900" b="1" kern="0" spc="300" dirty="0">
-                <a:solidFill>
-                  <a:srgbClr val="3BB77E"/>
+              <a:t>“Quality assurance is not just about testing expected behavior — it’s also about validating failure paths and catching risks before users do.”</a:t>
+            </a:r>
+          </a:p>
+          <a:p>
+            <a:pPr marL="0" indent="0">
+              <a:buNone/>
+            </a:pPr>
+            <a:endParaRPr lang="en-US" sz="950" i="1" dirty="0">
+              <a:solidFill>
+                <a:srgbClr val="B0C4D8"/>
+              </a:solidFill>
+              <a:latin typeface="Calibri" pitchFamily="34" charset="0"/>
+              <a:ea typeface="Calibri" pitchFamily="34" charset="-122"/>
+              <a:cs typeface="Calibri" pitchFamily="34" charset="-120"/>
+            </a:endParaRPr>
+          </a:p>
+          <a:p>
+            <a:pPr marL="0" indent="0">
+              <a:buNone/>
+            </a:pPr>
+            <a:r>
+              <a:rPr lang="en-US" sz="950" i="1" dirty="0">
+                <a:solidFill>
+                  <a:srgbClr val="B0C4D8"/>
                 </a:solidFill>
                 <a:latin typeface="Calibri" pitchFamily="34" charset="0"/>
                 <a:ea typeface="Calibri" pitchFamily="34" charset="-122"/>
                 <a:cs typeface="Calibri" pitchFamily="34" charset="-120"/>
               </a:rPr>
+              <a:t>Discover → Report → Fix → Retest → Document &amp; Expand Test Coverage</a:t>
+            </a:r>
+          </a:p>
+        </p:txBody>
+      </p:sp>
+      <p:sp>
+        <p:nvSpPr>
+          <p:cNvPr id="44" name="Text 0">
+            <a:extLst>
+              <a:ext uri="{FF2B5EF4-FFF2-40B4-BE49-F238E27FC236}">
+                <a16:creationId xmlns:a16="http://schemas.microsoft.com/office/drawing/2014/main" id="{C5C0EFD2-6E84-EEAA-2C5D-E7D613F3D090}"/>
+              </a:ext>
+            </a:extLst>
+          </p:cNvPr>
+          <p:cNvSpPr/>
+          <p:nvPr/>
+        </p:nvSpPr>
+        <p:spPr>
+          <a:xfrm>
+            <a:off x="457200" y="164592"/>
+            <a:ext cx="8229600" cy="256032"/>
+          </a:xfrm>
+          <a:prstGeom prst="rect">
+            <a:avLst/>
+          </a:prstGeom>
+          <a:noFill/>
+          <a:ln/>
+        </p:spPr>
+        <p:txBody>
+          <a:bodyPr wrap="square" lIns="0" tIns="0" rIns="0" bIns="0" rtlCol="0" anchor="ctr"/>
+          <a:lstStyle/>
+          <a:p>
+            <a:pPr marL="0" indent="0" algn="l">
+              <a:buNone/>
+            </a:pPr>
+            <a:r>
+              <a:rPr lang="en-US" sz="900" b="1" kern="0" spc="300" dirty="0">
+                <a:solidFill>
+                  <a:srgbClr val="3BB77E"/>
+                </a:solidFill>
+                <a:latin typeface="Calibri" pitchFamily="34" charset="0"/>
+                <a:ea typeface="Calibri" pitchFamily="34" charset="-122"/>
+                <a:cs typeface="Calibri" pitchFamily="34" charset="-120"/>
+              </a:rPr>
               <a:t>TESTING &amp; QUALITY ASSURANCE</a:t>
             </a:r>
             <a:endParaRPr lang="en-US" sz="900" dirty="0"/>
@@ -11772,10 +13222,10 @@
       </p:sp>
       <p:sp>
         <p:nvSpPr>
-          <p:cNvPr id="25" name="Text 1">
-            <a:extLst>
-              <a:ext uri="{FF2B5EF4-FFF2-40B4-BE49-F238E27FC236}">
-                <a16:creationId xmlns:a16="http://schemas.microsoft.com/office/drawing/2014/main" id="{59ADE286-38D8-DCFF-A976-DED8A4930314}"/>
+          <p:cNvPr id="45" name="Text 1">
+            <a:extLst>
+              <a:ext uri="{FF2B5EF4-FFF2-40B4-BE49-F238E27FC236}">
+                <a16:creationId xmlns:a16="http://schemas.microsoft.com/office/drawing/2014/main" id="{81365837-215A-0122-3E38-059B611400F7}"/>
               </a:ext>
             </a:extLst>
           </p:cNvPr>
@@ -11820,10 +13270,10 @@
       </p:sp>
       <p:sp>
         <p:nvSpPr>
-          <p:cNvPr id="26" name="Text 2">
-            <a:extLst>
-              <a:ext uri="{FF2B5EF4-FFF2-40B4-BE49-F238E27FC236}">
-                <a16:creationId xmlns:a16="http://schemas.microsoft.com/office/drawing/2014/main" id="{B47AD6B9-62CE-F716-2950-4C29024360E0}"/>
+          <p:cNvPr id="46" name="Text 2">
+            <a:extLst>
+              <a:ext uri="{FF2B5EF4-FFF2-40B4-BE49-F238E27FC236}">
+                <a16:creationId xmlns:a16="http://schemas.microsoft.com/office/drawing/2014/main" id="{4E3427C6-F076-33E2-8ADF-F1D0224A0826}"/>
               </a:ext>
             </a:extLst>
           </p:cNvPr>
@@ -11862,10 +13312,10 @@
       </p:sp>
       <p:sp>
         <p:nvSpPr>
-          <p:cNvPr id="27" name="Text 3">
-            <a:extLst>
-              <a:ext uri="{FF2B5EF4-FFF2-40B4-BE49-F238E27FC236}">
-                <a16:creationId xmlns:a16="http://schemas.microsoft.com/office/drawing/2014/main" id="{E0AF6E58-2AB3-26D3-3F77-3015CBE22786}"/>
+          <p:cNvPr id="47" name="Text 3">
+            <a:extLst>
+              <a:ext uri="{FF2B5EF4-FFF2-40B4-BE49-F238E27FC236}">
+                <a16:creationId xmlns:a16="http://schemas.microsoft.com/office/drawing/2014/main" id="{5C03824C-743E-5358-0AD7-FCF0A780E37E}"/>
               </a:ext>
             </a:extLst>
           </p:cNvPr>

</xml_diff>